<commit_message>
Add a quality analysis slide; next steps moves up after contribution
The quality table earns the phrase 'at matched quality': PSNR inside the brain, SSIM
and Dice for the low-res input, the baseline and ours, read from the validation run at
build time. If those rows were not level, the erasure difference would be a quality
difference wearing a safety costume.

Next steps now follows contribution, before the method and the results, in both the
HTML deck and the pptx. Eight slides each.
</commit_message>
<xml_diff>
--- a/deck.pptx
+++ b/deck.pptx
@@ -12,6 +12,7 @@
     <p:sldId id="260" r:id="rId11"/>
     <p:sldId id="261" r:id="rId12"/>
     <p:sldId id="262" r:id="rId13"/>
+    <p:sldId id="263" r:id="rId14"/>
   </p:sldIdLst>
   <p:sldSz cx="12191695" cy="6858000" type="screen4x3"/>
   <p:notesSz cx="6858000" cy="9144000"/>
@@ -4425,7 +4426,7 @@
                 </a:solidFill>
                 <a:latin typeface="Menlo"/>
               </a:rPr>
-              <a:t>03  METHOD</a:t>
+              <a:t>06  NEXT STEPS</a:t>
             </a:r>
           </a:p>
         </p:txBody>
@@ -4541,41 +4542,61 @@
               </a:lnSpc>
             </a:pPr>
             <a:r>
-              <a:rPr sz="2700" b="1">
+              <a:rPr sz="3000" b="1">
                 <a:solidFill>
                   <a:srgbClr val="14201B"/>
                 </a:solidFill>
                 <a:latin typeface="Helvetica Neue"/>
               </a:rPr>
-              <a:t>Degrade a real scan, reconstruct it two ways, and ask one frozen segmentation network what it can still find.</a:t>
-            </a:r>
-          </a:p>
-        </p:txBody>
-      </p:sp>
-      <p:pic>
-        <p:nvPicPr>
-          <p:cNvPr id="6" name="Picture 5" descr="architecture.png"/>
-          <p:cNvPicPr>
-            <a:picLocks noChangeAspect="1"/>
-          </p:cNvPicPr>
-          <p:nvPr/>
-        </p:nvPicPr>
-        <p:blipFill>
-          <a:blip r:embed="rId2"/>
-          <a:stretch>
-            <a:fillRect/>
-          </a:stretch>
-        </p:blipFill>
-        <p:spPr>
-          <a:xfrm>
-            <a:off x="658368" y="2834640"/>
-            <a:ext cx="10874959" cy="4079077"/>
-          </a:xfrm>
-          <a:prstGeom prst="rect">
-            <a:avLst/>
-          </a:prstGeom>
-        </p:spPr>
-      </p:pic>
+              <a:t>Next: generative models, tested with the readout we just built.</a:t>
+            </a:r>
+          </a:p>
+        </p:txBody>
+      </p:sp>
+      <p:sp>
+        <p:nvSpPr>
+          <p:cNvPr id="6" name="Rectangle 5"/>
+          <p:cNvSpPr/>
+          <p:nvPr/>
+        </p:nvSpPr>
+        <p:spPr>
+          <a:xfrm>
+            <a:off x="658368" y="2651760"/>
+            <a:ext cx="50292" cy="2194560"/>
+          </a:xfrm>
+          <a:prstGeom prst="rect">
+            <a:avLst/>
+          </a:prstGeom>
+          <a:solidFill>
+            <a:srgbClr val="EB6834"/>
+          </a:solidFill>
+          <a:ln>
+            <a:noFill/>
+          </a:ln>
+          <a:effectLst/>
+        </p:spPr>
+        <p:style>
+          <a:lnRef idx="1">
+            <a:schemeClr val="accent1"/>
+          </a:lnRef>
+          <a:fillRef idx="3">
+            <a:schemeClr val="accent1"/>
+          </a:fillRef>
+          <a:effectRef idx="2">
+            <a:schemeClr val="accent1"/>
+          </a:effectRef>
+          <a:fontRef idx="minor">
+            <a:schemeClr val="lt1"/>
+          </a:fontRef>
+        </p:style>
+        <p:txBody>
+          <a:bodyPr rtlCol="0" anchor="ctr"/>
+          <a:lstStyle/>
+          <a:p>
+            <a:pPr algn="ctr"/>
+          </a:p>
+        </p:txBody>
+      </p:sp>
       <p:sp>
         <p:nvSpPr>
           <p:cNvPr id="7" name="TextBox 6"/>
@@ -4584,7 +4605,329 @@
         </p:nvSpPr>
         <p:spPr>
           <a:xfrm>
-            <a:off x="658368" y="6035040"/>
+            <a:off x="914400" y="2651760"/>
+            <a:ext cx="2991002" cy="457200"/>
+          </a:xfrm>
+          <a:prstGeom prst="rect">
+            <a:avLst/>
+          </a:prstGeom>
+          <a:noFill/>
+        </p:spPr>
+        <p:txBody>
+          <a:bodyPr wrap="square">
+            <a:spAutoFit/>
+          </a:bodyPr>
+          <a:lstStyle/>
+          <a:p>
+            <a:pPr algn="l">
+              <a:lnSpc>
+                <a:spcPct val="115000"/>
+              </a:lnSpc>
+            </a:pPr>
+            <a:r>
+              <a:rPr sz="2000" b="1">
+                <a:solidFill>
+                  <a:srgbClr val="14201B"/>
+                </a:solidFill>
+                <a:latin typeface="Helvetica Neue"/>
+              </a:rPr>
+              <a:t>Why generative</a:t>
+            </a:r>
+          </a:p>
+        </p:txBody>
+      </p:sp>
+      <p:sp>
+        <p:nvSpPr>
+          <p:cNvPr id="8" name="TextBox 7"/>
+          <p:cNvSpPr txBox="1"/>
+          <p:nvPr/>
+        </p:nvSpPr>
+        <p:spPr>
+          <a:xfrm>
+            <a:off x="914400" y="3154680"/>
+            <a:ext cx="2991002" cy="1645920"/>
+          </a:xfrm>
+          <a:prstGeom prst="rect">
+            <a:avLst/>
+          </a:prstGeom>
+          <a:noFill/>
+        </p:spPr>
+        <p:txBody>
+          <a:bodyPr wrap="square">
+            <a:spAutoFit/>
+          </a:bodyPr>
+          <a:lstStyle/>
+          <a:p>
+            <a:pPr algn="l">
+              <a:lnSpc>
+                <a:spcPct val="125000"/>
+              </a:lnSpc>
+            </a:pPr>
+            <a:r>
+              <a:rPr sz="1600" b="0">
+                <a:solidFill>
+                  <a:srgbClr val="3D4A44"/>
+                </a:solidFill>
+                <a:latin typeface="Helvetica Neue"/>
+              </a:rPr>
+              <a:t>Diffusion and adversarial models make the sharpest low-field images anyone has produced. They are also the ones most likely to invent tissue.</a:t>
+            </a:r>
+          </a:p>
+        </p:txBody>
+      </p:sp>
+      <p:sp>
+        <p:nvSpPr>
+          <p:cNvPr id="9" name="Rectangle 8"/>
+          <p:cNvSpPr/>
+          <p:nvPr/>
+        </p:nvSpPr>
+        <p:spPr>
+          <a:xfrm>
+            <a:off x="4435754" y="2651760"/>
+            <a:ext cx="50292" cy="2194560"/>
+          </a:xfrm>
+          <a:prstGeom prst="rect">
+            <a:avLst/>
+          </a:prstGeom>
+          <a:solidFill>
+            <a:srgbClr val="1BAF7A"/>
+          </a:solidFill>
+          <a:ln>
+            <a:noFill/>
+          </a:ln>
+          <a:effectLst/>
+        </p:spPr>
+        <p:style>
+          <a:lnRef idx="1">
+            <a:schemeClr val="accent1"/>
+          </a:lnRef>
+          <a:fillRef idx="3">
+            <a:schemeClr val="accent1"/>
+          </a:fillRef>
+          <a:effectRef idx="2">
+            <a:schemeClr val="accent1"/>
+          </a:effectRef>
+          <a:fontRef idx="minor">
+            <a:schemeClr val="lt1"/>
+          </a:fontRef>
+        </p:style>
+        <p:txBody>
+          <a:bodyPr rtlCol="0" anchor="ctr"/>
+          <a:lstStyle/>
+          <a:p>
+            <a:pPr algn="ctr"/>
+          </a:p>
+        </p:txBody>
+      </p:sp>
+      <p:sp>
+        <p:nvSpPr>
+          <p:cNvPr id="10" name="TextBox 9"/>
+          <p:cNvSpPr txBox="1"/>
+          <p:nvPr/>
+        </p:nvSpPr>
+        <p:spPr>
+          <a:xfrm>
+            <a:off x="4691786" y="2651760"/>
+            <a:ext cx="2991002" cy="457200"/>
+          </a:xfrm>
+          <a:prstGeom prst="rect">
+            <a:avLst/>
+          </a:prstGeom>
+          <a:noFill/>
+        </p:spPr>
+        <p:txBody>
+          <a:bodyPr wrap="square">
+            <a:spAutoFit/>
+          </a:bodyPr>
+          <a:lstStyle/>
+          <a:p>
+            <a:pPr algn="l">
+              <a:lnSpc>
+                <a:spcPct val="115000"/>
+              </a:lnSpc>
+            </a:pPr>
+            <a:r>
+              <a:rPr sz="2000" b="1">
+                <a:solidFill>
+                  <a:srgbClr val="14201B"/>
+                </a:solidFill>
+                <a:latin typeface="Helvetica Neue"/>
+              </a:rPr>
+              <a:t>Why we can now try them</a:t>
+            </a:r>
+          </a:p>
+        </p:txBody>
+      </p:sp>
+      <p:sp>
+        <p:nvSpPr>
+          <p:cNvPr id="11" name="TextBox 10"/>
+          <p:cNvSpPr txBox="1"/>
+          <p:nvPr/>
+        </p:nvSpPr>
+        <p:spPr>
+          <a:xfrm>
+            <a:off x="4691786" y="3154680"/>
+            <a:ext cx="2991002" cy="1645920"/>
+          </a:xfrm>
+          <a:prstGeom prst="rect">
+            <a:avLst/>
+          </a:prstGeom>
+          <a:noFill/>
+        </p:spPr>
+        <p:txBody>
+          <a:bodyPr wrap="square">
+            <a:spAutoFit/>
+          </a:bodyPr>
+          <a:lstStyle/>
+          <a:p>
+            <a:pPr algn="l">
+              <a:lnSpc>
+                <a:spcPct val="125000"/>
+              </a:lnSpc>
+            </a:pPr>
+            <a:r>
+              <a:rPr sz="1600" b="0">
+                <a:solidFill>
+                  <a:srgbClr val="3D4A44"/>
+                </a:solidFill>
+                <a:latin typeface="Helvetica Neue"/>
+              </a:rPr>
+              <a:t>We can measure what they lose and what they fabricate. Sharpness no longer has to be taken on trust.</a:t>
+            </a:r>
+          </a:p>
+        </p:txBody>
+      </p:sp>
+      <p:sp>
+        <p:nvSpPr>
+          <p:cNvPr id="12" name="Rectangle 11"/>
+          <p:cNvSpPr/>
+          <p:nvPr/>
+        </p:nvSpPr>
+        <p:spPr>
+          <a:xfrm>
+            <a:off x="8213140" y="2651760"/>
+            <a:ext cx="50292" cy="2194560"/>
+          </a:xfrm>
+          <a:prstGeom prst="rect">
+            <a:avLst/>
+          </a:prstGeom>
+          <a:solidFill>
+            <a:srgbClr val="6B7772"/>
+          </a:solidFill>
+          <a:ln>
+            <a:noFill/>
+          </a:ln>
+          <a:effectLst/>
+        </p:spPr>
+        <p:style>
+          <a:lnRef idx="1">
+            <a:schemeClr val="accent1"/>
+          </a:lnRef>
+          <a:fillRef idx="3">
+            <a:schemeClr val="accent1"/>
+          </a:fillRef>
+          <a:effectRef idx="2">
+            <a:schemeClr val="accent1"/>
+          </a:effectRef>
+          <a:fontRef idx="minor">
+            <a:schemeClr val="lt1"/>
+          </a:fontRef>
+        </p:style>
+        <p:txBody>
+          <a:bodyPr rtlCol="0" anchor="ctr"/>
+          <a:lstStyle/>
+          <a:p>
+            <a:pPr algn="ctr"/>
+          </a:p>
+        </p:txBody>
+      </p:sp>
+      <p:sp>
+        <p:nvSpPr>
+          <p:cNvPr id="13" name="TextBox 12"/>
+          <p:cNvSpPr txBox="1"/>
+          <p:nvPr/>
+        </p:nvSpPr>
+        <p:spPr>
+          <a:xfrm>
+            <a:off x="8469172" y="2651760"/>
+            <a:ext cx="2991002" cy="457200"/>
+          </a:xfrm>
+          <a:prstGeom prst="rect">
+            <a:avLst/>
+          </a:prstGeom>
+          <a:noFill/>
+        </p:spPr>
+        <p:txBody>
+          <a:bodyPr wrap="square">
+            <a:spAutoFit/>
+          </a:bodyPr>
+          <a:lstStyle/>
+          <a:p>
+            <a:pPr algn="l">
+              <a:lnSpc>
+                <a:spcPct val="115000"/>
+              </a:lnSpc>
+            </a:pPr>
+            <a:r>
+              <a:rPr sz="2000" b="1">
+                <a:solidFill>
+                  <a:srgbClr val="14201B"/>
+                </a:solidFill>
+                <a:latin typeface="Helvetica Neue"/>
+              </a:rPr>
+              <a:t>Then the one number</a:t>
+            </a:r>
+          </a:p>
+        </p:txBody>
+      </p:sp>
+      <p:sp>
+        <p:nvSpPr>
+          <p:cNvPr id="14" name="TextBox 13"/>
+          <p:cNvSpPr txBox="1"/>
+          <p:nvPr/>
+        </p:nvSpPr>
+        <p:spPr>
+          <a:xfrm>
+            <a:off x="8469172" y="3154680"/>
+            <a:ext cx="2991002" cy="1645920"/>
+          </a:xfrm>
+          <a:prstGeom prst="rect">
+            <a:avLst/>
+          </a:prstGeom>
+          <a:noFill/>
+        </p:spPr>
+        <p:txBody>
+          <a:bodyPr wrap="square">
+            <a:spAutoFit/>
+          </a:bodyPr>
+          <a:lstStyle/>
+          <a:p>
+            <a:pPr algn="l">
+              <a:lnSpc>
+                <a:spcPct val="125000"/>
+              </a:lnSpc>
+            </a:pPr>
+            <a:r>
+              <a:rPr sz="1600" b="0">
+                <a:solidFill>
+                  <a:srgbClr val="3D4A44"/>
+                </a:solidFill>
+                <a:latin typeface="Helvetica Neue"/>
+              </a:rPr>
+              <a:t>A single evaluation on the 94 patients nothing has touched.</a:t>
+            </a:r>
+          </a:p>
+        </p:txBody>
+      </p:sp>
+      <p:sp>
+        <p:nvSpPr>
+          <p:cNvPr id="15" name="TextBox 14"/>
+          <p:cNvSpPr txBox="1"/>
+          <p:nvPr/>
+        </p:nvSpPr>
+        <p:spPr>
+          <a:xfrm>
+            <a:off x="658368" y="5212080"/>
             <a:ext cx="10874959" cy="548640"/>
           </a:xfrm>
           <a:prstGeom prst="rect">
@@ -4610,7 +4953,7 @@
                 </a:solidFill>
                 <a:latin typeface="Helvetica Neue"/>
               </a:rPr>
-              <a:t>No GAN, deliberately: an adversarial loss rewards inventing plausible tissue. 17,233 slices, 468 patients.</a:t>
+              <a:t>A safety metric is what makes a generative model testable rather than impressive.</a:t>
             </a:r>
           </a:p>
         </p:txBody>
@@ -4675,7 +5018,7 @@
                 </a:solidFill>
                 <a:latin typeface="Menlo"/>
               </a:rPr>
-              <a:t>04  RESULT  ·  REAL BRATS, 70 UNSEEN PATIENTS</a:t>
+              <a:t>03  METHOD</a:t>
             </a:r>
           </a:p>
         </p:txBody>
@@ -4791,371 +5134,20 @@
               </a:lnSpc>
             </a:pPr>
             <a:r>
-              <a:rPr sz="3000" b="1">
+              <a:rPr sz="2700" b="1">
                 <a:solidFill>
                   <a:srgbClr val="14201B"/>
                 </a:solidFill>
                 <a:latin typeface="Helvetica Neue"/>
               </a:rPr>
-              <a:t>Super-resolution recovers tumor the degradation destroys. Ours recovers more of it.</a:t>
-            </a:r>
-          </a:p>
-        </p:txBody>
-      </p:sp>
-      <p:sp>
-        <p:nvSpPr>
-          <p:cNvPr id="6" name="TextBox 5"/>
-          <p:cNvSpPr txBox="1"/>
-          <p:nvPr/>
-        </p:nvSpPr>
-        <p:spPr>
-          <a:xfrm>
-            <a:off x="658368" y="2423160"/>
-            <a:ext cx="3320186" cy="868680"/>
-          </a:xfrm>
-          <a:prstGeom prst="rect">
-            <a:avLst/>
-          </a:prstGeom>
-          <a:noFill/>
-        </p:spPr>
-        <p:txBody>
-          <a:bodyPr wrap="square">
-            <a:spAutoFit/>
-          </a:bodyPr>
-          <a:lstStyle/>
-          <a:p>
-            <a:pPr algn="l">
-              <a:lnSpc>
-                <a:spcPct val="115000"/>
-              </a:lnSpc>
-            </a:pPr>
-            <a:r>
-              <a:rPr sz="4400" b="1">
-                <a:solidFill>
-                  <a:srgbClr val="6B7772"/>
-                </a:solidFill>
-                <a:latin typeface="Menlo"/>
-              </a:rPr>
-              <a:t>62.2%</a:t>
-            </a:r>
-          </a:p>
-        </p:txBody>
-      </p:sp>
-      <p:sp>
-        <p:nvSpPr>
-          <p:cNvPr id="7" name="TextBox 6"/>
-          <p:cNvSpPr txBox="1"/>
-          <p:nvPr/>
-        </p:nvSpPr>
-        <p:spPr>
-          <a:xfrm>
-            <a:off x="658368" y="3291840"/>
-            <a:ext cx="3320186" cy="365760"/>
-          </a:xfrm>
-          <a:prstGeom prst="rect">
-            <a:avLst/>
-          </a:prstGeom>
-          <a:noFill/>
-        </p:spPr>
-        <p:txBody>
-          <a:bodyPr wrap="square">
-            <a:spAutoFit/>
-          </a:bodyPr>
-          <a:lstStyle/>
-          <a:p>
-            <a:pPr algn="l">
-              <a:lnSpc>
-                <a:spcPct val="115000"/>
-              </a:lnSpc>
-            </a:pPr>
-            <a:r>
-              <a:rPr sz="1700" b="1">
-                <a:solidFill>
-                  <a:srgbClr val="14201B"/>
-                </a:solidFill>
-                <a:latin typeface="Helvetica Neue"/>
-              </a:rPr>
-              <a:t>The degraded scan</a:t>
-            </a:r>
-          </a:p>
-        </p:txBody>
-      </p:sp>
-      <p:sp>
-        <p:nvSpPr>
-          <p:cNvPr id="8" name="TextBox 7"/>
-          <p:cNvSpPr txBox="1"/>
-          <p:nvPr/>
-        </p:nvSpPr>
-        <p:spPr>
-          <a:xfrm>
-            <a:off x="658368" y="3657600"/>
-            <a:ext cx="3320186" cy="914400"/>
-          </a:xfrm>
-          <a:prstGeom prst="rect">
-            <a:avLst/>
-          </a:prstGeom>
-          <a:noFill/>
-        </p:spPr>
-        <p:txBody>
-          <a:bodyPr wrap="square">
-            <a:spAutoFit/>
-          </a:bodyPr>
-          <a:lstStyle/>
-          <a:p>
-            <a:pPr algn="l">
-              <a:lnSpc>
-                <a:spcPct val="120000"/>
-              </a:lnSpc>
-            </a:pPr>
-            <a:r>
-              <a:rPr sz="1500" b="0">
-                <a:solidFill>
-                  <a:srgbClr val="6B7772"/>
-                </a:solidFill>
-                <a:latin typeface="Helvetica Neue"/>
-              </a:rPr>
-              <a:t>missed before any reconstruction</a:t>
-            </a:r>
-          </a:p>
-        </p:txBody>
-      </p:sp>
-      <p:sp>
-        <p:nvSpPr>
-          <p:cNvPr id="9" name="TextBox 8"/>
-          <p:cNvSpPr txBox="1"/>
-          <p:nvPr/>
-        </p:nvSpPr>
-        <p:spPr>
-          <a:xfrm>
-            <a:off x="4435754" y="2423160"/>
-            <a:ext cx="3320186" cy="868680"/>
-          </a:xfrm>
-          <a:prstGeom prst="rect">
-            <a:avLst/>
-          </a:prstGeom>
-          <a:noFill/>
-        </p:spPr>
-        <p:txBody>
-          <a:bodyPr wrap="square">
-            <a:spAutoFit/>
-          </a:bodyPr>
-          <a:lstStyle/>
-          <a:p>
-            <a:pPr algn="l">
-              <a:lnSpc>
-                <a:spcPct val="115000"/>
-              </a:lnSpc>
-            </a:pPr>
-            <a:r>
-              <a:rPr sz="4400" b="1">
-                <a:solidFill>
-                  <a:srgbClr val="EB6834"/>
-                </a:solidFill>
-                <a:latin typeface="Menlo"/>
-              </a:rPr>
-              <a:t>58.0%</a:t>
-            </a:r>
-          </a:p>
-        </p:txBody>
-      </p:sp>
-      <p:sp>
-        <p:nvSpPr>
-          <p:cNvPr id="10" name="TextBox 9"/>
-          <p:cNvSpPr txBox="1"/>
-          <p:nvPr/>
-        </p:nvSpPr>
-        <p:spPr>
-          <a:xfrm>
-            <a:off x="4435754" y="3291840"/>
-            <a:ext cx="3320186" cy="365760"/>
-          </a:xfrm>
-          <a:prstGeom prst="rect">
-            <a:avLst/>
-          </a:prstGeom>
-          <a:noFill/>
-        </p:spPr>
-        <p:txBody>
-          <a:bodyPr wrap="square">
-            <a:spAutoFit/>
-          </a:bodyPr>
-          <a:lstStyle/>
-          <a:p>
-            <a:pPr algn="l">
-              <a:lnSpc>
-                <a:spcPct val="115000"/>
-              </a:lnSpc>
-            </a:pPr>
-            <a:r>
-              <a:rPr sz="1700" b="1">
-                <a:solidFill>
-                  <a:srgbClr val="14201B"/>
-                </a:solidFill>
-                <a:latin typeface="Helvetica Neue"/>
-              </a:rPr>
-              <a:t>Standard SR (baseline)</a:t>
-            </a:r>
-          </a:p>
-        </p:txBody>
-      </p:sp>
-      <p:sp>
-        <p:nvSpPr>
-          <p:cNvPr id="11" name="TextBox 10"/>
-          <p:cNvSpPr txBox="1"/>
-          <p:nvPr/>
-        </p:nvSpPr>
-        <p:spPr>
-          <a:xfrm>
-            <a:off x="4435754" y="3657600"/>
-            <a:ext cx="3320186" cy="914400"/>
-          </a:xfrm>
-          <a:prstGeom prst="rect">
-            <a:avLst/>
-          </a:prstGeom>
-          <a:noFill/>
-        </p:spPr>
-        <p:txBody>
-          <a:bodyPr wrap="square">
-            <a:spAutoFit/>
-          </a:bodyPr>
-          <a:lstStyle/>
-          <a:p>
-            <a:pPr algn="l">
-              <a:lnSpc>
-                <a:spcPct val="120000"/>
-              </a:lnSpc>
-            </a:pPr>
-            <a:r>
-              <a:rPr sz="1500" b="0">
-                <a:solidFill>
-                  <a:srgbClr val="6B7772"/>
-                </a:solidFill>
-                <a:latin typeface="Helvetica Neue"/>
-              </a:rPr>
-              <a:t>recovers some of it</a:t>
-            </a:r>
-          </a:p>
-        </p:txBody>
-      </p:sp>
-      <p:sp>
-        <p:nvSpPr>
-          <p:cNvPr id="12" name="TextBox 11"/>
-          <p:cNvSpPr txBox="1"/>
-          <p:nvPr/>
-        </p:nvSpPr>
-        <p:spPr>
-          <a:xfrm>
-            <a:off x="8213140" y="2423160"/>
-            <a:ext cx="3320186" cy="868680"/>
-          </a:xfrm>
-          <a:prstGeom prst="rect">
-            <a:avLst/>
-          </a:prstGeom>
-          <a:noFill/>
-        </p:spPr>
-        <p:txBody>
-          <a:bodyPr wrap="square">
-            <a:spAutoFit/>
-          </a:bodyPr>
-          <a:lstStyle/>
-          <a:p>
-            <a:pPr algn="l">
-              <a:lnSpc>
-                <a:spcPct val="115000"/>
-              </a:lnSpc>
-            </a:pPr>
-            <a:r>
-              <a:rPr sz="4400" b="1">
-                <a:solidFill>
-                  <a:srgbClr val="1BAF7A"/>
-                </a:solidFill>
-                <a:latin typeface="Menlo"/>
-              </a:rPr>
-              <a:t>51.3%</a:t>
-            </a:r>
-          </a:p>
-        </p:txBody>
-      </p:sp>
-      <p:sp>
-        <p:nvSpPr>
-          <p:cNvPr id="13" name="TextBox 12"/>
-          <p:cNvSpPr txBox="1"/>
-          <p:nvPr/>
-        </p:nvSpPr>
-        <p:spPr>
-          <a:xfrm>
-            <a:off x="8213140" y="3291840"/>
-            <a:ext cx="3320186" cy="365760"/>
-          </a:xfrm>
-          <a:prstGeom prst="rect">
-            <a:avLst/>
-          </a:prstGeom>
-          <a:noFill/>
-        </p:spPr>
-        <p:txBody>
-          <a:bodyPr wrap="square">
-            <a:spAutoFit/>
-          </a:bodyPr>
-          <a:lstStyle/>
-          <a:p>
-            <a:pPr algn="l">
-              <a:lnSpc>
-                <a:spcPct val="115000"/>
-              </a:lnSpc>
-            </a:pPr>
-            <a:r>
-              <a:rPr sz="1700" b="1">
-                <a:solidFill>
-                  <a:srgbClr val="14201B"/>
-                </a:solidFill>
-                <a:latin typeface="Helvetica Neue"/>
-              </a:rPr>
-              <a:t>Tumor-aware SR (ours)</a:t>
-            </a:r>
-          </a:p>
-        </p:txBody>
-      </p:sp>
-      <p:sp>
-        <p:nvSpPr>
-          <p:cNvPr id="14" name="TextBox 13"/>
-          <p:cNvSpPr txBox="1"/>
-          <p:nvPr/>
-        </p:nvSpPr>
-        <p:spPr>
-          <a:xfrm>
-            <a:off x="8213140" y="3657600"/>
-            <a:ext cx="3320186" cy="914400"/>
-          </a:xfrm>
-          <a:prstGeom prst="rect">
-            <a:avLst/>
-          </a:prstGeom>
-          <a:noFill/>
-        </p:spPr>
-        <p:txBody>
-          <a:bodyPr wrap="square">
-            <a:spAutoFit/>
-          </a:bodyPr>
-          <a:lstStyle/>
-          <a:p>
-            <a:pPr algn="l">
-              <a:lnSpc>
-                <a:spcPct val="120000"/>
-              </a:lnSpc>
-            </a:pPr>
-            <a:r>
-              <a:rPr sz="1500" b="0">
-                <a:solidFill>
-                  <a:srgbClr val="6B7772"/>
-                </a:solidFill>
-                <a:latin typeface="Helvetica Neue"/>
-              </a:rPr>
-              <a:t>6.7 points better, at matched quality</a:t>
+              <a:t>Degrade a real scan, reconstruct it two ways, and ask one frozen segmentation network what it can still find.</a:t>
             </a:r>
           </a:p>
         </p:txBody>
       </p:sp>
       <p:pic>
         <p:nvPicPr>
-          <p:cNvPr id="15" name="Picture 14" descr="floor_by_size.png"/>
+          <p:cNvPr id="6" name="Picture 5" descr="architecture.png"/>
           <p:cNvPicPr>
             <a:picLocks noChangeAspect="1"/>
           </p:cNvPicPr>
@@ -5169,8 +5161,8 @@
         </p:blipFill>
         <p:spPr>
           <a:xfrm>
-            <a:off x="658368" y="4114800"/>
-            <a:ext cx="4303059" cy="2286000"/>
+            <a:off x="658368" y="2834640"/>
+            <a:ext cx="10874959" cy="4079077"/>
           </a:xfrm>
           <a:prstGeom prst="rect">
             <a:avLst/>
@@ -5179,14 +5171,14 @@
       </p:pic>
       <p:sp>
         <p:nvSpPr>
-          <p:cNvPr id="16" name="TextBox 15"/>
-          <p:cNvSpPr txBox="1"/>
-          <p:nvPr/>
-        </p:nvSpPr>
-        <p:spPr>
-          <a:xfrm>
-            <a:off x="6510528" y="4297680"/>
-            <a:ext cx="5223967" cy="2011680"/>
+          <p:cNvPr id="7" name="TextBox 6"/>
+          <p:cNvSpPr txBox="1"/>
+          <p:nvPr/>
+        </p:nvSpPr>
+        <p:spPr>
+          <a:xfrm>
+            <a:off x="658368" y="6035040"/>
+            <a:ext cx="10874959" cy="548640"/>
           </a:xfrm>
           <a:prstGeom prst="rect">
             <a:avLst/>
@@ -5201,17 +5193,17 @@
           <a:p>
             <a:pPr algn="l">
               <a:lnSpc>
-                <a:spcPct val="125000"/>
+                <a:spcPct val="115000"/>
               </a:lnSpc>
             </a:pPr>
             <a:r>
               <a:rPr sz="1600" b="0">
                 <a:solidFill>
-                  <a:srgbClr val="3D4A44"/>
+                  <a:srgbClr val="6B7772"/>
                 </a:solidFill>
                 <a:latin typeface="Helvetica Neue"/>
               </a:rPr>
-              <a:t>Grey is what the frozen segmenter misses on the untouched scan. The block above it is what each objective adds: standard SR in orange, ours in green.</a:t>
+              <a:t>No GAN, deliberately: an adversarial loss rewards inventing plausible tissue. 17,233 slices, 468 patients.</a:t>
             </a:r>
           </a:p>
         </p:txBody>
@@ -5276,7 +5268,7 @@
                 </a:solidFill>
                 <a:latin typeface="Menlo"/>
               </a:rPr>
-              <a:t>05  RESULT  ·  FOUR VIEWPORTS</a:t>
+              <a:t>04  RESULT  ·  REAL BRATS, 70 UNSEEN PATIENTS</a:t>
             </a:r>
           </a:p>
         </p:txBody>
@@ -5398,14 +5390,365 @@
                 </a:solidFill>
                 <a:latin typeface="Helvetica Neue"/>
               </a:rPr>
-              <a:t>The lesions the baseline loses show up in 3D as empty blue shells.</a:t>
+              <a:t>Super-resolution recovers tumor the degradation destroys. Ours recovers more of it.</a:t>
+            </a:r>
+          </a:p>
+        </p:txBody>
+      </p:sp>
+      <p:sp>
+        <p:nvSpPr>
+          <p:cNvPr id="6" name="TextBox 5"/>
+          <p:cNvSpPr txBox="1"/>
+          <p:nvPr/>
+        </p:nvSpPr>
+        <p:spPr>
+          <a:xfrm>
+            <a:off x="658368" y="2423160"/>
+            <a:ext cx="3320186" cy="868680"/>
+          </a:xfrm>
+          <a:prstGeom prst="rect">
+            <a:avLst/>
+          </a:prstGeom>
+          <a:noFill/>
+        </p:spPr>
+        <p:txBody>
+          <a:bodyPr wrap="square">
+            <a:spAutoFit/>
+          </a:bodyPr>
+          <a:lstStyle/>
+          <a:p>
+            <a:pPr algn="l">
+              <a:lnSpc>
+                <a:spcPct val="115000"/>
+              </a:lnSpc>
+            </a:pPr>
+            <a:r>
+              <a:rPr sz="4400" b="1">
+                <a:solidFill>
+                  <a:srgbClr val="6B7772"/>
+                </a:solidFill>
+                <a:latin typeface="Menlo"/>
+              </a:rPr>
+              <a:t>62.2%</a:t>
+            </a:r>
+          </a:p>
+        </p:txBody>
+      </p:sp>
+      <p:sp>
+        <p:nvSpPr>
+          <p:cNvPr id="7" name="TextBox 6"/>
+          <p:cNvSpPr txBox="1"/>
+          <p:nvPr/>
+        </p:nvSpPr>
+        <p:spPr>
+          <a:xfrm>
+            <a:off x="658368" y="3291840"/>
+            <a:ext cx="3320186" cy="365760"/>
+          </a:xfrm>
+          <a:prstGeom prst="rect">
+            <a:avLst/>
+          </a:prstGeom>
+          <a:noFill/>
+        </p:spPr>
+        <p:txBody>
+          <a:bodyPr wrap="square">
+            <a:spAutoFit/>
+          </a:bodyPr>
+          <a:lstStyle/>
+          <a:p>
+            <a:pPr algn="l">
+              <a:lnSpc>
+                <a:spcPct val="115000"/>
+              </a:lnSpc>
+            </a:pPr>
+            <a:r>
+              <a:rPr sz="1700" b="1">
+                <a:solidFill>
+                  <a:srgbClr val="14201B"/>
+                </a:solidFill>
+                <a:latin typeface="Helvetica Neue"/>
+              </a:rPr>
+              <a:t>The degraded scan</a:t>
+            </a:r>
+          </a:p>
+        </p:txBody>
+      </p:sp>
+      <p:sp>
+        <p:nvSpPr>
+          <p:cNvPr id="8" name="TextBox 7"/>
+          <p:cNvSpPr txBox="1"/>
+          <p:nvPr/>
+        </p:nvSpPr>
+        <p:spPr>
+          <a:xfrm>
+            <a:off x="658368" y="3657600"/>
+            <a:ext cx="3320186" cy="914400"/>
+          </a:xfrm>
+          <a:prstGeom prst="rect">
+            <a:avLst/>
+          </a:prstGeom>
+          <a:noFill/>
+        </p:spPr>
+        <p:txBody>
+          <a:bodyPr wrap="square">
+            <a:spAutoFit/>
+          </a:bodyPr>
+          <a:lstStyle/>
+          <a:p>
+            <a:pPr algn="l">
+              <a:lnSpc>
+                <a:spcPct val="120000"/>
+              </a:lnSpc>
+            </a:pPr>
+            <a:r>
+              <a:rPr sz="1500" b="0">
+                <a:solidFill>
+                  <a:srgbClr val="6B7772"/>
+                </a:solidFill>
+                <a:latin typeface="Helvetica Neue"/>
+              </a:rPr>
+              <a:t>missed before any reconstruction</a:t>
+            </a:r>
+          </a:p>
+        </p:txBody>
+      </p:sp>
+      <p:sp>
+        <p:nvSpPr>
+          <p:cNvPr id="9" name="TextBox 8"/>
+          <p:cNvSpPr txBox="1"/>
+          <p:nvPr/>
+        </p:nvSpPr>
+        <p:spPr>
+          <a:xfrm>
+            <a:off x="4435754" y="2423160"/>
+            <a:ext cx="3320186" cy="868680"/>
+          </a:xfrm>
+          <a:prstGeom prst="rect">
+            <a:avLst/>
+          </a:prstGeom>
+          <a:noFill/>
+        </p:spPr>
+        <p:txBody>
+          <a:bodyPr wrap="square">
+            <a:spAutoFit/>
+          </a:bodyPr>
+          <a:lstStyle/>
+          <a:p>
+            <a:pPr algn="l">
+              <a:lnSpc>
+                <a:spcPct val="115000"/>
+              </a:lnSpc>
+            </a:pPr>
+            <a:r>
+              <a:rPr sz="4400" b="1">
+                <a:solidFill>
+                  <a:srgbClr val="EB6834"/>
+                </a:solidFill>
+                <a:latin typeface="Menlo"/>
+              </a:rPr>
+              <a:t>58.0%</a:t>
+            </a:r>
+          </a:p>
+        </p:txBody>
+      </p:sp>
+      <p:sp>
+        <p:nvSpPr>
+          <p:cNvPr id="10" name="TextBox 9"/>
+          <p:cNvSpPr txBox="1"/>
+          <p:nvPr/>
+        </p:nvSpPr>
+        <p:spPr>
+          <a:xfrm>
+            <a:off x="4435754" y="3291840"/>
+            <a:ext cx="3320186" cy="365760"/>
+          </a:xfrm>
+          <a:prstGeom prst="rect">
+            <a:avLst/>
+          </a:prstGeom>
+          <a:noFill/>
+        </p:spPr>
+        <p:txBody>
+          <a:bodyPr wrap="square">
+            <a:spAutoFit/>
+          </a:bodyPr>
+          <a:lstStyle/>
+          <a:p>
+            <a:pPr algn="l">
+              <a:lnSpc>
+                <a:spcPct val="115000"/>
+              </a:lnSpc>
+            </a:pPr>
+            <a:r>
+              <a:rPr sz="1700" b="1">
+                <a:solidFill>
+                  <a:srgbClr val="14201B"/>
+                </a:solidFill>
+                <a:latin typeface="Helvetica Neue"/>
+              </a:rPr>
+              <a:t>Standard SR (baseline)</a:t>
+            </a:r>
+          </a:p>
+        </p:txBody>
+      </p:sp>
+      <p:sp>
+        <p:nvSpPr>
+          <p:cNvPr id="11" name="TextBox 10"/>
+          <p:cNvSpPr txBox="1"/>
+          <p:nvPr/>
+        </p:nvSpPr>
+        <p:spPr>
+          <a:xfrm>
+            <a:off x="4435754" y="3657600"/>
+            <a:ext cx="3320186" cy="914400"/>
+          </a:xfrm>
+          <a:prstGeom prst="rect">
+            <a:avLst/>
+          </a:prstGeom>
+          <a:noFill/>
+        </p:spPr>
+        <p:txBody>
+          <a:bodyPr wrap="square">
+            <a:spAutoFit/>
+          </a:bodyPr>
+          <a:lstStyle/>
+          <a:p>
+            <a:pPr algn="l">
+              <a:lnSpc>
+                <a:spcPct val="120000"/>
+              </a:lnSpc>
+            </a:pPr>
+            <a:r>
+              <a:rPr sz="1500" b="0">
+                <a:solidFill>
+                  <a:srgbClr val="6B7772"/>
+                </a:solidFill>
+                <a:latin typeface="Helvetica Neue"/>
+              </a:rPr>
+              <a:t>recovers some of it</a:t>
+            </a:r>
+          </a:p>
+        </p:txBody>
+      </p:sp>
+      <p:sp>
+        <p:nvSpPr>
+          <p:cNvPr id="12" name="TextBox 11"/>
+          <p:cNvSpPr txBox="1"/>
+          <p:nvPr/>
+        </p:nvSpPr>
+        <p:spPr>
+          <a:xfrm>
+            <a:off x="8213140" y="2423160"/>
+            <a:ext cx="3320186" cy="868680"/>
+          </a:xfrm>
+          <a:prstGeom prst="rect">
+            <a:avLst/>
+          </a:prstGeom>
+          <a:noFill/>
+        </p:spPr>
+        <p:txBody>
+          <a:bodyPr wrap="square">
+            <a:spAutoFit/>
+          </a:bodyPr>
+          <a:lstStyle/>
+          <a:p>
+            <a:pPr algn="l">
+              <a:lnSpc>
+                <a:spcPct val="115000"/>
+              </a:lnSpc>
+            </a:pPr>
+            <a:r>
+              <a:rPr sz="4400" b="1">
+                <a:solidFill>
+                  <a:srgbClr val="1BAF7A"/>
+                </a:solidFill>
+                <a:latin typeface="Menlo"/>
+              </a:rPr>
+              <a:t>51.3%</a:t>
+            </a:r>
+          </a:p>
+        </p:txBody>
+      </p:sp>
+      <p:sp>
+        <p:nvSpPr>
+          <p:cNvPr id="13" name="TextBox 12"/>
+          <p:cNvSpPr txBox="1"/>
+          <p:nvPr/>
+        </p:nvSpPr>
+        <p:spPr>
+          <a:xfrm>
+            <a:off x="8213140" y="3291840"/>
+            <a:ext cx="3320186" cy="365760"/>
+          </a:xfrm>
+          <a:prstGeom prst="rect">
+            <a:avLst/>
+          </a:prstGeom>
+          <a:noFill/>
+        </p:spPr>
+        <p:txBody>
+          <a:bodyPr wrap="square">
+            <a:spAutoFit/>
+          </a:bodyPr>
+          <a:lstStyle/>
+          <a:p>
+            <a:pPr algn="l">
+              <a:lnSpc>
+                <a:spcPct val="115000"/>
+              </a:lnSpc>
+            </a:pPr>
+            <a:r>
+              <a:rPr sz="1700" b="1">
+                <a:solidFill>
+                  <a:srgbClr val="14201B"/>
+                </a:solidFill>
+                <a:latin typeface="Helvetica Neue"/>
+              </a:rPr>
+              <a:t>Tumor-aware SR (ours)</a:t>
+            </a:r>
+          </a:p>
+        </p:txBody>
+      </p:sp>
+      <p:sp>
+        <p:nvSpPr>
+          <p:cNvPr id="14" name="TextBox 13"/>
+          <p:cNvSpPr txBox="1"/>
+          <p:nvPr/>
+        </p:nvSpPr>
+        <p:spPr>
+          <a:xfrm>
+            <a:off x="8213140" y="3657600"/>
+            <a:ext cx="3320186" cy="914400"/>
+          </a:xfrm>
+          <a:prstGeom prst="rect">
+            <a:avLst/>
+          </a:prstGeom>
+          <a:noFill/>
+        </p:spPr>
+        <p:txBody>
+          <a:bodyPr wrap="square">
+            <a:spAutoFit/>
+          </a:bodyPr>
+          <a:lstStyle/>
+          <a:p>
+            <a:pPr algn="l">
+              <a:lnSpc>
+                <a:spcPct val="120000"/>
+              </a:lnSpc>
+            </a:pPr>
+            <a:r>
+              <a:rPr sz="1500" b="0">
+                <a:solidFill>
+                  <a:srgbClr val="6B7772"/>
+                </a:solidFill>
+                <a:latin typeface="Helvetica Neue"/>
+              </a:rPr>
+              <a:t>6.7 points better, at matched quality</a:t>
             </a:r>
           </a:p>
         </p:txBody>
       </p:sp>
       <p:pic>
         <p:nvPicPr>
-          <p:cNvPr id="6" name="Picture 5" descr="brain3d_true.png"/>
+          <p:cNvPr id="15" name="Picture 14" descr="floor_by_size.png"/>
           <p:cNvPicPr>
             <a:picLocks noChangeAspect="1"/>
           </p:cNvPicPr>
@@ -5419,8 +5762,8 @@
         </p:blipFill>
         <p:spPr>
           <a:xfrm>
-            <a:off x="658368" y="2606040"/>
-            <a:ext cx="2526715" cy="2403461"/>
+            <a:off x="658368" y="4114800"/>
+            <a:ext cx="4303059" cy="2286000"/>
           </a:xfrm>
           <a:prstGeom prst="rect">
             <a:avLst/>
@@ -5429,14 +5772,14 @@
       </p:pic>
       <p:sp>
         <p:nvSpPr>
-          <p:cNvPr id="7" name="TextBox 6"/>
-          <p:cNvSpPr txBox="1"/>
-          <p:nvPr/>
-        </p:nvSpPr>
-        <p:spPr>
-          <a:xfrm>
-            <a:off x="658368" y="5242483"/>
-            <a:ext cx="2526715" cy="365760"/>
+          <p:cNvPr id="16" name="TextBox 15"/>
+          <p:cNvSpPr txBox="1"/>
+          <p:nvPr/>
+        </p:nvSpPr>
+        <p:spPr>
+          <a:xfrm>
+            <a:off x="6510528" y="4297680"/>
+            <a:ext cx="5223967" cy="2011680"/>
           </a:xfrm>
           <a:prstGeom prst="rect">
             <a:avLst/>
@@ -5451,401 +5794,17 @@
           <a:p>
             <a:pPr algn="l">
               <a:lnSpc>
-                <a:spcPct val="115000"/>
-              </a:lnSpc>
-            </a:pPr>
-            <a:r>
-              <a:rPr sz="1700" b="1">
-                <a:solidFill>
-                  <a:srgbClr val="14201B"/>
+                <a:spcPct val="125000"/>
+              </a:lnSpc>
+            </a:pPr>
+            <a:r>
+              <a:rPr sz="1600" b="0">
+                <a:solidFill>
+                  <a:srgbClr val="3D4A44"/>
                 </a:solidFill>
                 <a:latin typeface="Helvetica Neue"/>
               </a:rPr>
-              <a:t>Ground truth</a:t>
-            </a:r>
-          </a:p>
-        </p:txBody>
-      </p:sp>
-      <p:sp>
-        <p:nvSpPr>
-          <p:cNvPr id="8" name="TextBox 7"/>
-          <p:cNvSpPr txBox="1"/>
-          <p:nvPr/>
-        </p:nvSpPr>
-        <p:spPr>
-          <a:xfrm>
-            <a:off x="658368" y="5589955"/>
-            <a:ext cx="2526715" cy="548640"/>
-          </a:xfrm>
-          <a:prstGeom prst="rect">
-            <a:avLst/>
-          </a:prstGeom>
-          <a:noFill/>
-        </p:spPr>
-        <p:txBody>
-          <a:bodyPr wrap="square">
-            <a:spAutoFit/>
-          </a:bodyPr>
-          <a:lstStyle/>
-          <a:p>
-            <a:pPr algn="l">
-              <a:lnSpc>
-                <a:spcPct val="115000"/>
-              </a:lnSpc>
-            </a:pPr>
-            <a:r>
-              <a:rPr sz="1400" b="0">
-                <a:solidFill>
-                  <a:srgbClr val="6B7772"/>
-                </a:solidFill>
-                <a:latin typeface="Helvetica Neue"/>
-              </a:rPr>
-              <a:t>the true lesions, in blue</a:t>
-            </a:r>
-          </a:p>
-        </p:txBody>
-      </p:sp>
-      <p:pic>
-        <p:nvPicPr>
-          <p:cNvPr id="9" name="Picture 8" descr="brain3d_tumor_aware.png"/>
-          <p:cNvPicPr>
-            <a:picLocks noChangeAspect="1"/>
-          </p:cNvPicPr>
-          <p:nvPr/>
-        </p:nvPicPr>
-        <p:blipFill>
-          <a:blip r:embed="rId3"/>
-          <a:stretch>
-            <a:fillRect/>
-          </a:stretch>
-        </p:blipFill>
-        <p:spPr>
-          <a:xfrm>
-            <a:off x="3441115" y="2606040"/>
-            <a:ext cx="2526715" cy="2403461"/>
-          </a:xfrm>
-          <a:prstGeom prst="rect">
-            <a:avLst/>
-          </a:prstGeom>
-        </p:spPr>
-      </p:pic>
-      <p:sp>
-        <p:nvSpPr>
-          <p:cNvPr id="10" name="TextBox 9"/>
-          <p:cNvSpPr txBox="1"/>
-          <p:nvPr/>
-        </p:nvSpPr>
-        <p:spPr>
-          <a:xfrm>
-            <a:off x="3441115" y="5242483"/>
-            <a:ext cx="2526715" cy="365760"/>
-          </a:xfrm>
-          <a:prstGeom prst="rect">
-            <a:avLst/>
-          </a:prstGeom>
-          <a:noFill/>
-        </p:spPr>
-        <p:txBody>
-          <a:bodyPr wrap="square">
-            <a:spAutoFit/>
-          </a:bodyPr>
-          <a:lstStyle/>
-          <a:p>
-            <a:pPr algn="l">
-              <a:lnSpc>
-                <a:spcPct val="115000"/>
-              </a:lnSpc>
-            </a:pPr>
-            <a:r>
-              <a:rPr sz="1700" b="1">
-                <a:solidFill>
-                  <a:srgbClr val="14201B"/>
-                </a:solidFill>
-                <a:latin typeface="Helvetica Neue"/>
-              </a:rPr>
-              <a:t>Tumor-aware (ours)</a:t>
-            </a:r>
-          </a:p>
-        </p:txBody>
-      </p:sp>
-      <p:sp>
-        <p:nvSpPr>
-          <p:cNvPr id="11" name="TextBox 10"/>
-          <p:cNvSpPr txBox="1"/>
-          <p:nvPr/>
-        </p:nvSpPr>
-        <p:spPr>
-          <a:xfrm>
-            <a:off x="3441115" y="5589955"/>
-            <a:ext cx="2526715" cy="548640"/>
-          </a:xfrm>
-          <a:prstGeom prst="rect">
-            <a:avLst/>
-          </a:prstGeom>
-          <a:noFill/>
-        </p:spPr>
-        <p:txBody>
-          <a:bodyPr wrap="square">
-            <a:spAutoFit/>
-          </a:bodyPr>
-          <a:lstStyle/>
-          <a:p>
-            <a:pPr algn="l">
-              <a:lnSpc>
-                <a:spcPct val="115000"/>
-              </a:lnSpc>
-            </a:pPr>
-            <a:r>
-              <a:rPr sz="1400" b="0">
-                <a:solidFill>
-                  <a:srgbClr val="6B7772"/>
-                </a:solidFill>
-                <a:latin typeface="Helvetica Neue"/>
-              </a:rPr>
-              <a:t>lesions preserved</a:t>
-            </a:r>
-          </a:p>
-        </p:txBody>
-      </p:sp>
-      <p:pic>
-        <p:nvPicPr>
-          <p:cNvPr id="12" name="Picture 11" descr="brain3d_distortion.png"/>
-          <p:cNvPicPr>
-            <a:picLocks noChangeAspect="1"/>
-          </p:cNvPicPr>
-          <p:nvPr/>
-        </p:nvPicPr>
-        <p:blipFill>
-          <a:blip r:embed="rId4"/>
-          <a:stretch>
-            <a:fillRect/>
-          </a:stretch>
-        </p:blipFill>
-        <p:spPr>
-          <a:xfrm>
-            <a:off x="6223863" y="2606040"/>
-            <a:ext cx="2526715" cy="2403461"/>
-          </a:xfrm>
-          <a:prstGeom prst="rect">
-            <a:avLst/>
-          </a:prstGeom>
-        </p:spPr>
-      </p:pic>
-      <p:sp>
-        <p:nvSpPr>
-          <p:cNvPr id="13" name="TextBox 12"/>
-          <p:cNvSpPr txBox="1"/>
-          <p:nvPr/>
-        </p:nvSpPr>
-        <p:spPr>
-          <a:xfrm>
-            <a:off x="6223863" y="5242483"/>
-            <a:ext cx="2526715" cy="365760"/>
-          </a:xfrm>
-          <a:prstGeom prst="rect">
-            <a:avLst/>
-          </a:prstGeom>
-          <a:noFill/>
-        </p:spPr>
-        <p:txBody>
-          <a:bodyPr wrap="square">
-            <a:spAutoFit/>
-          </a:bodyPr>
-          <a:lstStyle/>
-          <a:p>
-            <a:pPr algn="l">
-              <a:lnSpc>
-                <a:spcPct val="115000"/>
-              </a:lnSpc>
-            </a:pPr>
-            <a:r>
-              <a:rPr sz="1700" b="1">
-                <a:solidFill>
-                  <a:srgbClr val="14201B"/>
-                </a:solidFill>
-                <a:latin typeface="Helvetica Neue"/>
-              </a:rPr>
-              <a:t>Baseline</a:t>
-            </a:r>
-          </a:p>
-        </p:txBody>
-      </p:sp>
-      <p:sp>
-        <p:nvSpPr>
-          <p:cNvPr id="14" name="TextBox 13"/>
-          <p:cNvSpPr txBox="1"/>
-          <p:nvPr/>
-        </p:nvSpPr>
-        <p:spPr>
-          <a:xfrm>
-            <a:off x="6223863" y="5589955"/>
-            <a:ext cx="2526715" cy="548640"/>
-          </a:xfrm>
-          <a:prstGeom prst="rect">
-            <a:avLst/>
-          </a:prstGeom>
-          <a:noFill/>
-        </p:spPr>
-        <p:txBody>
-          <a:bodyPr wrap="square">
-            <a:spAutoFit/>
-          </a:bodyPr>
-          <a:lstStyle/>
-          <a:p>
-            <a:pPr algn="l">
-              <a:lnSpc>
-                <a:spcPct val="115000"/>
-              </a:lnSpc>
-            </a:pPr>
-            <a:r>
-              <a:rPr sz="1400" b="0">
-                <a:solidFill>
-                  <a:srgbClr val="6B7772"/>
-                </a:solidFill>
-                <a:latin typeface="Helvetica Neue"/>
-              </a:rPr>
-              <a:t>small lesions dropped</a:t>
-            </a:r>
-          </a:p>
-        </p:txBody>
-      </p:sp>
-      <p:pic>
-        <p:nvPicPr>
-          <p:cNvPr id="15" name="Picture 14" descr="brain3d_uncertainty.png"/>
-          <p:cNvPicPr>
-            <a:picLocks noChangeAspect="1"/>
-          </p:cNvPicPr>
-          <p:nvPr/>
-        </p:nvPicPr>
-        <p:blipFill>
-          <a:blip r:embed="rId5"/>
-          <a:stretch>
-            <a:fillRect/>
-          </a:stretch>
-        </p:blipFill>
-        <p:spPr>
-          <a:xfrm>
-            <a:off x="9006611" y="2606040"/>
-            <a:ext cx="2526715" cy="2403461"/>
-          </a:xfrm>
-          <a:prstGeom prst="rect">
-            <a:avLst/>
-          </a:prstGeom>
-        </p:spPr>
-      </p:pic>
-      <p:sp>
-        <p:nvSpPr>
-          <p:cNvPr id="16" name="TextBox 15"/>
-          <p:cNvSpPr txBox="1"/>
-          <p:nvPr/>
-        </p:nvSpPr>
-        <p:spPr>
-          <a:xfrm>
-            <a:off x="9006611" y="5242483"/>
-            <a:ext cx="2526715" cy="365760"/>
-          </a:xfrm>
-          <a:prstGeom prst="rect">
-            <a:avLst/>
-          </a:prstGeom>
-          <a:noFill/>
-        </p:spPr>
-        <p:txBody>
-          <a:bodyPr wrap="square">
-            <a:spAutoFit/>
-          </a:bodyPr>
-          <a:lstStyle/>
-          <a:p>
-            <a:pPr algn="l">
-              <a:lnSpc>
-                <a:spcPct val="115000"/>
-              </a:lnSpc>
-            </a:pPr>
-            <a:r>
-              <a:rPr sz="1700" b="1">
-                <a:solidFill>
-                  <a:srgbClr val="14201B"/>
-                </a:solidFill>
-                <a:latin typeface="Helvetica Neue"/>
-              </a:rPr>
-              <a:t>Uncertainty</a:t>
-            </a:r>
-          </a:p>
-        </p:txBody>
-      </p:sp>
-      <p:sp>
-        <p:nvSpPr>
-          <p:cNvPr id="17" name="TextBox 16"/>
-          <p:cNvSpPr txBox="1"/>
-          <p:nvPr/>
-        </p:nvSpPr>
-        <p:spPr>
-          <a:xfrm>
-            <a:off x="9006611" y="5589955"/>
-            <a:ext cx="2526715" cy="548640"/>
-          </a:xfrm>
-          <a:prstGeom prst="rect">
-            <a:avLst/>
-          </a:prstGeom>
-          <a:noFill/>
-        </p:spPr>
-        <p:txBody>
-          <a:bodyPr wrap="square">
-            <a:spAutoFit/>
-          </a:bodyPr>
-          <a:lstStyle/>
-          <a:p>
-            <a:pPr algn="l">
-              <a:lnSpc>
-                <a:spcPct val="115000"/>
-              </a:lnSpc>
-            </a:pPr>
-            <a:r>
-              <a:rPr sz="1400" b="0">
-                <a:solidFill>
-                  <a:srgbClr val="6B7772"/>
-                </a:solidFill>
-                <a:latin typeface="Helvetica Neue"/>
-              </a:rPr>
-              <a:t>where the model is unsure</a:t>
-            </a:r>
-          </a:p>
-        </p:txBody>
-      </p:sp>
-      <p:sp>
-        <p:nvSpPr>
-          <p:cNvPr id="18" name="TextBox 17"/>
-          <p:cNvSpPr txBox="1"/>
-          <p:nvPr/>
-        </p:nvSpPr>
-        <p:spPr>
-          <a:xfrm>
-            <a:off x="658368" y="6172200"/>
-            <a:ext cx="10874959" cy="457200"/>
-          </a:xfrm>
-          <a:prstGeom prst="rect">
-            <a:avLst/>
-          </a:prstGeom>
-          <a:noFill/>
-        </p:spPr>
-        <p:txBody>
-          <a:bodyPr wrap="square">
-            <a:spAutoFit/>
-          </a:bodyPr>
-          <a:lstStyle/>
-          <a:p>
-            <a:pPr algn="l">
-              <a:lnSpc>
-                <a:spcPct val="115000"/>
-              </a:lnSpc>
-            </a:pPr>
-            <a:r>
-              <a:rPr sz="1600" b="0">
-                <a:solidFill>
-                  <a:srgbClr val="6B7772"/>
-                </a:solidFill>
-                <a:latin typeface="Helvetica Neue"/>
-              </a:rPr>
-              <a:t>A blue shell with nothing inside it is a lesion the model lost.</a:t>
+              <a:t>Grey is what the frozen segmenter misses on the untouched scan. The block above it is what each objective adds: standard SR in orange, ours in green.</a:t>
             </a:r>
           </a:p>
         </p:txBody>
@@ -5910,7 +5869,7 @@
                 </a:solidFill>
                 <a:latin typeface="Menlo"/>
               </a:rPr>
-              <a:t>06  NEXT STEPS</a:t>
+              <a:t>04  RESULT  ·  IMAGE QUALITY</a:t>
             </a:r>
           </a:p>
         </p:txBody>
@@ -6032,27 +5991,183 @@
                 </a:solidFill>
                 <a:latin typeface="Helvetica Neue"/>
               </a:rPr>
-              <a:t>Next: generative models, tested with the readout we just built.</a:t>
-            </a:r>
-          </a:p>
-        </p:txBody>
-      </p:sp>
-      <p:sp>
-        <p:nvSpPr>
-          <p:cNvPr id="6" name="Rectangle 5"/>
+              <a:t>The two reconstructions are level on every quality metric we are judged by.</a:t>
+            </a:r>
+          </a:p>
+        </p:txBody>
+      </p:sp>
+      <p:sp>
+        <p:nvSpPr>
+          <p:cNvPr id="6" name="TextBox 5"/>
+          <p:cNvSpPr txBox="1"/>
+          <p:nvPr/>
+        </p:nvSpPr>
+        <p:spPr>
+          <a:xfrm>
+            <a:off x="658368" y="2651760"/>
+            <a:ext cx="4206240" cy="457200"/>
+          </a:xfrm>
+          <a:prstGeom prst="rect">
+            <a:avLst/>
+          </a:prstGeom>
+          <a:noFill/>
+        </p:spPr>
+        <p:txBody>
+          <a:bodyPr wrap="square">
+            <a:spAutoFit/>
+          </a:bodyPr>
+          <a:lstStyle/>
+          <a:p>
+            <a:pPr algn="l">
+              <a:lnSpc>
+                <a:spcPct val="115000"/>
+              </a:lnSpc>
+            </a:pPr>
+            <a:r>
+              <a:rPr sz="1400" b="0">
+                <a:solidFill>
+                  <a:srgbClr val="6B7772"/>
+                </a:solidFill>
+                <a:latin typeface="Menlo"/>
+              </a:rPr>
+              <a:t>IMAGE</a:t>
+            </a:r>
+          </a:p>
+        </p:txBody>
+      </p:sp>
+      <p:sp>
+        <p:nvSpPr>
+          <p:cNvPr id="7" name="TextBox 6"/>
+          <p:cNvSpPr txBox="1"/>
+          <p:nvPr/>
+        </p:nvSpPr>
+        <p:spPr>
+          <a:xfrm>
+            <a:off x="4864608" y="2651760"/>
+            <a:ext cx="2194560" cy="457200"/>
+          </a:xfrm>
+          <a:prstGeom prst="rect">
+            <a:avLst/>
+          </a:prstGeom>
+          <a:noFill/>
+        </p:spPr>
+        <p:txBody>
+          <a:bodyPr wrap="square">
+            <a:spAutoFit/>
+          </a:bodyPr>
+          <a:lstStyle/>
+          <a:p>
+            <a:pPr algn="l">
+              <a:lnSpc>
+                <a:spcPct val="115000"/>
+              </a:lnSpc>
+            </a:pPr>
+            <a:r>
+              <a:rPr sz="1400" b="0">
+                <a:solidFill>
+                  <a:srgbClr val="6B7772"/>
+                </a:solidFill>
+                <a:latin typeface="Menlo"/>
+              </a:rPr>
+              <a:t>PSNR (DB), IN BRAIN</a:t>
+            </a:r>
+          </a:p>
+        </p:txBody>
+      </p:sp>
+      <p:sp>
+        <p:nvSpPr>
+          <p:cNvPr id="8" name="TextBox 7"/>
+          <p:cNvSpPr txBox="1"/>
+          <p:nvPr/>
+        </p:nvSpPr>
+        <p:spPr>
+          <a:xfrm>
+            <a:off x="7059168" y="2651760"/>
+            <a:ext cx="1828800" cy="457200"/>
+          </a:xfrm>
+          <a:prstGeom prst="rect">
+            <a:avLst/>
+          </a:prstGeom>
+          <a:noFill/>
+        </p:spPr>
+        <p:txBody>
+          <a:bodyPr wrap="square">
+            <a:spAutoFit/>
+          </a:bodyPr>
+          <a:lstStyle/>
+          <a:p>
+            <a:pPr algn="l">
+              <a:lnSpc>
+                <a:spcPct val="115000"/>
+              </a:lnSpc>
+            </a:pPr>
+            <a:r>
+              <a:rPr sz="1400" b="0">
+                <a:solidFill>
+                  <a:srgbClr val="6B7772"/>
+                </a:solidFill>
+                <a:latin typeface="Menlo"/>
+              </a:rPr>
+              <a:t>SSIM</a:t>
+            </a:r>
+          </a:p>
+        </p:txBody>
+      </p:sp>
+      <p:sp>
+        <p:nvSpPr>
+          <p:cNvPr id="9" name="TextBox 8"/>
+          <p:cNvSpPr txBox="1"/>
+          <p:nvPr/>
+        </p:nvSpPr>
+        <p:spPr>
+          <a:xfrm>
+            <a:off x="8887968" y="2651760"/>
+            <a:ext cx="2194560" cy="457200"/>
+          </a:xfrm>
+          <a:prstGeom prst="rect">
+            <a:avLst/>
+          </a:prstGeom>
+          <a:noFill/>
+        </p:spPr>
+        <p:txBody>
+          <a:bodyPr wrap="square">
+            <a:spAutoFit/>
+          </a:bodyPr>
+          <a:lstStyle/>
+          <a:p>
+            <a:pPr algn="l">
+              <a:lnSpc>
+                <a:spcPct val="115000"/>
+              </a:lnSpc>
+            </a:pPr>
+            <a:r>
+              <a:rPr sz="1400" b="0">
+                <a:solidFill>
+                  <a:srgbClr val="6B7772"/>
+                </a:solidFill>
+                <a:latin typeface="Menlo"/>
+              </a:rPr>
+              <a:t>DICE, SEGMENTER VS TRUTH</a:t>
+            </a:r>
+          </a:p>
+        </p:txBody>
+      </p:sp>
+      <p:sp>
+        <p:nvSpPr>
+          <p:cNvPr id="10" name="Rectangle 9"/>
           <p:cNvSpPr/>
           <p:nvPr/>
         </p:nvSpPr>
         <p:spPr>
           <a:xfrm>
-            <a:off x="658368" y="2651760"/>
-            <a:ext cx="50292" cy="2194560"/>
+            <a:off x="658368" y="3127248"/>
+            <a:ext cx="10874959" cy="9525"/>
           </a:xfrm>
           <a:prstGeom prst="rect">
             <a:avLst/>
           </a:prstGeom>
           <a:solidFill>
-            <a:srgbClr val="EB6834"/>
+            <a:srgbClr val="DBDBD2"/>
           </a:solidFill>
           <a:ln>
             <a:noFill/>
@@ -6083,14 +6198,14 @@
       </p:sp>
       <p:sp>
         <p:nvSpPr>
-          <p:cNvPr id="7" name="TextBox 6"/>
-          <p:cNvSpPr txBox="1"/>
-          <p:nvPr/>
-        </p:nvSpPr>
-        <p:spPr>
-          <a:xfrm>
-            <a:off x="914400" y="2651760"/>
-            <a:ext cx="2991002" cy="457200"/>
+          <p:cNvPr id="11" name="TextBox 10"/>
+          <p:cNvSpPr txBox="1"/>
+          <p:nvPr/>
+        </p:nvSpPr>
+        <p:spPr>
+          <a:xfrm>
+            <a:off x="658368" y="3310128"/>
+            <a:ext cx="4206240" cy="502920"/>
           </a:xfrm>
           <a:prstGeom prst="rect">
             <a:avLst/>
@@ -6109,27 +6224,66 @@
               </a:lnSpc>
             </a:pPr>
             <a:r>
-              <a:rPr sz="2000" b="1">
+              <a:rPr sz="1900" b="1">
+                <a:solidFill>
+                  <a:srgbClr val="6B7772"/>
+                </a:solidFill>
+                <a:latin typeface="Helvetica Neue"/>
+              </a:rPr>
+              <a:t>low-res input</a:t>
+            </a:r>
+          </a:p>
+        </p:txBody>
+      </p:sp>
+      <p:sp>
+        <p:nvSpPr>
+          <p:cNvPr id="12" name="TextBox 11"/>
+          <p:cNvSpPr txBox="1"/>
+          <p:nvPr/>
+        </p:nvSpPr>
+        <p:spPr>
+          <a:xfrm>
+            <a:off x="4864608" y="3310128"/>
+            <a:ext cx="2194560" cy="502920"/>
+          </a:xfrm>
+          <a:prstGeom prst="rect">
+            <a:avLst/>
+          </a:prstGeom>
+          <a:noFill/>
+        </p:spPr>
+        <p:txBody>
+          <a:bodyPr wrap="square">
+            <a:spAutoFit/>
+          </a:bodyPr>
+          <a:lstStyle/>
+          <a:p>
+            <a:pPr algn="l">
+              <a:lnSpc>
+                <a:spcPct val="115000"/>
+              </a:lnSpc>
+            </a:pPr>
+            <a:r>
+              <a:rPr sz="1900" b="0">
                 <a:solidFill>
                   <a:srgbClr val="14201B"/>
                 </a:solidFill>
-                <a:latin typeface="Helvetica Neue"/>
-              </a:rPr>
-              <a:t>Why generative</a:t>
-            </a:r>
-          </a:p>
-        </p:txBody>
-      </p:sp>
-      <p:sp>
-        <p:nvSpPr>
-          <p:cNvPr id="8" name="TextBox 7"/>
-          <p:cNvSpPr txBox="1"/>
-          <p:nvPr/>
-        </p:nvSpPr>
-        <p:spPr>
-          <a:xfrm>
-            <a:off x="914400" y="3154680"/>
-            <a:ext cx="2991002" cy="1645920"/>
+                <a:latin typeface="Menlo"/>
+              </a:rPr>
+              <a:t>21.84</a:t>
+            </a:r>
+          </a:p>
+        </p:txBody>
+      </p:sp>
+      <p:sp>
+        <p:nvSpPr>
+          <p:cNvPr id="13" name="TextBox 12"/>
+          <p:cNvSpPr txBox="1"/>
+          <p:nvPr/>
+        </p:nvSpPr>
+        <p:spPr>
+          <a:xfrm>
+            <a:off x="7059168" y="3310128"/>
+            <a:ext cx="1828800" cy="502920"/>
           </a:xfrm>
           <a:prstGeom prst="rect">
             <a:avLst/>
@@ -6144,37 +6298,76 @@
           <a:p>
             <a:pPr algn="l">
               <a:lnSpc>
-                <a:spcPct val="125000"/>
-              </a:lnSpc>
-            </a:pPr>
-            <a:r>
-              <a:rPr sz="1600" b="0">
-                <a:solidFill>
-                  <a:srgbClr val="3D4A44"/>
-                </a:solidFill>
-                <a:latin typeface="Helvetica Neue"/>
-              </a:rPr>
-              <a:t>Diffusion and adversarial models make the sharpest low-field images anyone has produced. They are also the ones most likely to invent tissue.</a:t>
-            </a:r>
-          </a:p>
-        </p:txBody>
-      </p:sp>
-      <p:sp>
-        <p:nvSpPr>
-          <p:cNvPr id="9" name="Rectangle 8"/>
+                <a:spcPct val="115000"/>
+              </a:lnSpc>
+            </a:pPr>
+            <a:r>
+              <a:rPr sz="1900" b="0">
+                <a:solidFill>
+                  <a:srgbClr val="14201B"/>
+                </a:solidFill>
+                <a:latin typeface="Menlo"/>
+              </a:rPr>
+              <a:t>0.498</a:t>
+            </a:r>
+          </a:p>
+        </p:txBody>
+      </p:sp>
+      <p:sp>
+        <p:nvSpPr>
+          <p:cNvPr id="14" name="TextBox 13"/>
+          <p:cNvSpPr txBox="1"/>
+          <p:nvPr/>
+        </p:nvSpPr>
+        <p:spPr>
+          <a:xfrm>
+            <a:off x="8887968" y="3310128"/>
+            <a:ext cx="2194560" cy="502920"/>
+          </a:xfrm>
+          <a:prstGeom prst="rect">
+            <a:avLst/>
+          </a:prstGeom>
+          <a:noFill/>
+        </p:spPr>
+        <p:txBody>
+          <a:bodyPr wrap="square">
+            <a:spAutoFit/>
+          </a:bodyPr>
+          <a:lstStyle/>
+          <a:p>
+            <a:pPr algn="l">
+              <a:lnSpc>
+                <a:spcPct val="115000"/>
+              </a:lnSpc>
+            </a:pPr>
+            <a:r>
+              <a:rPr sz="1900" b="0">
+                <a:solidFill>
+                  <a:srgbClr val="14201B"/>
+                </a:solidFill>
+                <a:latin typeface="Menlo"/>
+              </a:rPr>
+              <a:t>0.588</a:t>
+            </a:r>
+          </a:p>
+        </p:txBody>
+      </p:sp>
+      <p:sp>
+        <p:nvSpPr>
+          <p:cNvPr id="15" name="Rectangle 14"/>
           <p:cNvSpPr/>
           <p:nvPr/>
         </p:nvSpPr>
         <p:spPr>
           <a:xfrm>
-            <a:off x="4435754" y="2651760"/>
-            <a:ext cx="50292" cy="2194560"/>
+            <a:off x="658368" y="3858768"/>
+            <a:ext cx="10874959" cy="9525"/>
           </a:xfrm>
           <a:prstGeom prst="rect">
             <a:avLst/>
           </a:prstGeom>
           <a:solidFill>
-            <a:srgbClr val="1BAF7A"/>
+            <a:srgbClr val="DBDBD2"/>
           </a:solidFill>
           <a:ln>
             <a:noFill/>
@@ -6205,14 +6398,14 @@
       </p:sp>
       <p:sp>
         <p:nvSpPr>
-          <p:cNvPr id="10" name="TextBox 9"/>
-          <p:cNvSpPr txBox="1"/>
-          <p:nvPr/>
-        </p:nvSpPr>
-        <p:spPr>
-          <a:xfrm>
-            <a:off x="4691786" y="2651760"/>
-            <a:ext cx="2991002" cy="457200"/>
+          <p:cNvPr id="16" name="TextBox 15"/>
+          <p:cNvSpPr txBox="1"/>
+          <p:nvPr/>
+        </p:nvSpPr>
+        <p:spPr>
+          <a:xfrm>
+            <a:off x="658368" y="4059936"/>
+            <a:ext cx="4206240" cy="502920"/>
           </a:xfrm>
           <a:prstGeom prst="rect">
             <a:avLst/>
@@ -6231,27 +6424,66 @@
               </a:lnSpc>
             </a:pPr>
             <a:r>
-              <a:rPr sz="2000" b="1">
+              <a:rPr sz="1900" b="1">
+                <a:solidFill>
+                  <a:srgbClr val="EB6834"/>
+                </a:solidFill>
+                <a:latin typeface="Helvetica Neue"/>
+              </a:rPr>
+              <a:t>standard SR (baseline)</a:t>
+            </a:r>
+          </a:p>
+        </p:txBody>
+      </p:sp>
+      <p:sp>
+        <p:nvSpPr>
+          <p:cNvPr id="17" name="TextBox 16"/>
+          <p:cNvSpPr txBox="1"/>
+          <p:nvPr/>
+        </p:nvSpPr>
+        <p:spPr>
+          <a:xfrm>
+            <a:off x="4864608" y="4059936"/>
+            <a:ext cx="2194560" cy="502920"/>
+          </a:xfrm>
+          <a:prstGeom prst="rect">
+            <a:avLst/>
+          </a:prstGeom>
+          <a:noFill/>
+        </p:spPr>
+        <p:txBody>
+          <a:bodyPr wrap="square">
+            <a:spAutoFit/>
+          </a:bodyPr>
+          <a:lstStyle/>
+          <a:p>
+            <a:pPr algn="l">
+              <a:lnSpc>
+                <a:spcPct val="115000"/>
+              </a:lnSpc>
+            </a:pPr>
+            <a:r>
+              <a:rPr sz="1900" b="0">
                 <a:solidFill>
                   <a:srgbClr val="14201B"/>
                 </a:solidFill>
-                <a:latin typeface="Helvetica Neue"/>
-              </a:rPr>
-              <a:t>Why we can now try them</a:t>
-            </a:r>
-          </a:p>
-        </p:txBody>
-      </p:sp>
-      <p:sp>
-        <p:nvSpPr>
-          <p:cNvPr id="11" name="TextBox 10"/>
-          <p:cNvSpPr txBox="1"/>
-          <p:nvPr/>
-        </p:nvSpPr>
-        <p:spPr>
-          <a:xfrm>
-            <a:off x="4691786" y="3154680"/>
-            <a:ext cx="2991002" cy="1645920"/>
+                <a:latin typeface="Menlo"/>
+              </a:rPr>
+              <a:t>24.51</a:t>
+            </a:r>
+          </a:p>
+        </p:txBody>
+      </p:sp>
+      <p:sp>
+        <p:nvSpPr>
+          <p:cNvPr id="18" name="TextBox 17"/>
+          <p:cNvSpPr txBox="1"/>
+          <p:nvPr/>
+        </p:nvSpPr>
+        <p:spPr>
+          <a:xfrm>
+            <a:off x="7059168" y="4059936"/>
+            <a:ext cx="1828800" cy="502920"/>
           </a:xfrm>
           <a:prstGeom prst="rect">
             <a:avLst/>
@@ -6266,37 +6498,76 @@
           <a:p>
             <a:pPr algn="l">
               <a:lnSpc>
-                <a:spcPct val="125000"/>
-              </a:lnSpc>
-            </a:pPr>
-            <a:r>
-              <a:rPr sz="1600" b="0">
-                <a:solidFill>
-                  <a:srgbClr val="3D4A44"/>
-                </a:solidFill>
-                <a:latin typeface="Helvetica Neue"/>
-              </a:rPr>
-              <a:t>We can measure what they lose and what they fabricate. Sharpness no longer has to be taken on trust.</a:t>
-            </a:r>
-          </a:p>
-        </p:txBody>
-      </p:sp>
-      <p:sp>
-        <p:nvSpPr>
-          <p:cNvPr id="12" name="Rectangle 11"/>
+                <a:spcPct val="115000"/>
+              </a:lnSpc>
+            </a:pPr>
+            <a:r>
+              <a:rPr sz="1900" b="0">
+                <a:solidFill>
+                  <a:srgbClr val="14201B"/>
+                </a:solidFill>
+                <a:latin typeface="Menlo"/>
+              </a:rPr>
+              <a:t>0.778</a:t>
+            </a:r>
+          </a:p>
+        </p:txBody>
+      </p:sp>
+      <p:sp>
+        <p:nvSpPr>
+          <p:cNvPr id="19" name="TextBox 18"/>
+          <p:cNvSpPr txBox="1"/>
+          <p:nvPr/>
+        </p:nvSpPr>
+        <p:spPr>
+          <a:xfrm>
+            <a:off x="8887968" y="4059936"/>
+            <a:ext cx="2194560" cy="502920"/>
+          </a:xfrm>
+          <a:prstGeom prst="rect">
+            <a:avLst/>
+          </a:prstGeom>
+          <a:noFill/>
+        </p:spPr>
+        <p:txBody>
+          <a:bodyPr wrap="square">
+            <a:spAutoFit/>
+          </a:bodyPr>
+          <a:lstStyle/>
+          <a:p>
+            <a:pPr algn="l">
+              <a:lnSpc>
+                <a:spcPct val="115000"/>
+              </a:lnSpc>
+            </a:pPr>
+            <a:r>
+              <a:rPr sz="1900" b="0">
+                <a:solidFill>
+                  <a:srgbClr val="14201B"/>
+                </a:solidFill>
+                <a:latin typeface="Menlo"/>
+              </a:rPr>
+              <a:t>0.660</a:t>
+            </a:r>
+          </a:p>
+        </p:txBody>
+      </p:sp>
+      <p:sp>
+        <p:nvSpPr>
+          <p:cNvPr id="20" name="Rectangle 19"/>
           <p:cNvSpPr/>
           <p:nvPr/>
         </p:nvSpPr>
         <p:spPr>
           <a:xfrm>
-            <a:off x="8213140" y="2651760"/>
-            <a:ext cx="50292" cy="2194560"/>
+            <a:off x="658368" y="4608576"/>
+            <a:ext cx="10874959" cy="9525"/>
           </a:xfrm>
           <a:prstGeom prst="rect">
             <a:avLst/>
           </a:prstGeom>
           <a:solidFill>
-            <a:srgbClr val="6B7772"/>
+            <a:srgbClr val="DBDBD2"/>
           </a:solidFill>
           <a:ln>
             <a:noFill/>
@@ -6327,14 +6598,668 @@
       </p:sp>
       <p:sp>
         <p:nvSpPr>
+          <p:cNvPr id="21" name="TextBox 20"/>
+          <p:cNvSpPr txBox="1"/>
+          <p:nvPr/>
+        </p:nvSpPr>
+        <p:spPr>
+          <a:xfrm>
+            <a:off x="658368" y="4809744"/>
+            <a:ext cx="4206240" cy="502920"/>
+          </a:xfrm>
+          <a:prstGeom prst="rect">
+            <a:avLst/>
+          </a:prstGeom>
+          <a:noFill/>
+        </p:spPr>
+        <p:txBody>
+          <a:bodyPr wrap="square">
+            <a:spAutoFit/>
+          </a:bodyPr>
+          <a:lstStyle/>
+          <a:p>
+            <a:pPr algn="l">
+              <a:lnSpc>
+                <a:spcPct val="115000"/>
+              </a:lnSpc>
+            </a:pPr>
+            <a:r>
+              <a:rPr sz="1900" b="1">
+                <a:solidFill>
+                  <a:srgbClr val="1BAF7A"/>
+                </a:solidFill>
+                <a:latin typeface="Helvetica Neue"/>
+              </a:rPr>
+              <a:t>tumor-aware SR (ours)</a:t>
+            </a:r>
+          </a:p>
+        </p:txBody>
+      </p:sp>
+      <p:sp>
+        <p:nvSpPr>
+          <p:cNvPr id="22" name="TextBox 21"/>
+          <p:cNvSpPr txBox="1"/>
+          <p:nvPr/>
+        </p:nvSpPr>
+        <p:spPr>
+          <a:xfrm>
+            <a:off x="4864608" y="4809744"/>
+            <a:ext cx="2194560" cy="502920"/>
+          </a:xfrm>
+          <a:prstGeom prst="rect">
+            <a:avLst/>
+          </a:prstGeom>
+          <a:noFill/>
+        </p:spPr>
+        <p:txBody>
+          <a:bodyPr wrap="square">
+            <a:spAutoFit/>
+          </a:bodyPr>
+          <a:lstStyle/>
+          <a:p>
+            <a:pPr algn="l">
+              <a:lnSpc>
+                <a:spcPct val="115000"/>
+              </a:lnSpc>
+            </a:pPr>
+            <a:r>
+              <a:rPr sz="1900" b="0">
+                <a:solidFill>
+                  <a:srgbClr val="14201B"/>
+                </a:solidFill>
+                <a:latin typeface="Menlo"/>
+              </a:rPr>
+              <a:t>24.28</a:t>
+            </a:r>
+          </a:p>
+        </p:txBody>
+      </p:sp>
+      <p:sp>
+        <p:nvSpPr>
+          <p:cNvPr id="23" name="TextBox 22"/>
+          <p:cNvSpPr txBox="1"/>
+          <p:nvPr/>
+        </p:nvSpPr>
+        <p:spPr>
+          <a:xfrm>
+            <a:off x="7059168" y="4809744"/>
+            <a:ext cx="1828800" cy="502920"/>
+          </a:xfrm>
+          <a:prstGeom prst="rect">
+            <a:avLst/>
+          </a:prstGeom>
+          <a:noFill/>
+        </p:spPr>
+        <p:txBody>
+          <a:bodyPr wrap="square">
+            <a:spAutoFit/>
+          </a:bodyPr>
+          <a:lstStyle/>
+          <a:p>
+            <a:pPr algn="l">
+              <a:lnSpc>
+                <a:spcPct val="115000"/>
+              </a:lnSpc>
+            </a:pPr>
+            <a:r>
+              <a:rPr sz="1900" b="0">
+                <a:solidFill>
+                  <a:srgbClr val="14201B"/>
+                </a:solidFill>
+                <a:latin typeface="Menlo"/>
+              </a:rPr>
+              <a:t>0.764</a:t>
+            </a:r>
+          </a:p>
+        </p:txBody>
+      </p:sp>
+      <p:sp>
+        <p:nvSpPr>
+          <p:cNvPr id="24" name="TextBox 23"/>
+          <p:cNvSpPr txBox="1"/>
+          <p:nvPr/>
+        </p:nvSpPr>
+        <p:spPr>
+          <a:xfrm>
+            <a:off x="8887968" y="4809744"/>
+            <a:ext cx="2194560" cy="502920"/>
+          </a:xfrm>
+          <a:prstGeom prst="rect">
+            <a:avLst/>
+          </a:prstGeom>
+          <a:noFill/>
+        </p:spPr>
+        <p:txBody>
+          <a:bodyPr wrap="square">
+            <a:spAutoFit/>
+          </a:bodyPr>
+          <a:lstStyle/>
+          <a:p>
+            <a:pPr algn="l">
+              <a:lnSpc>
+                <a:spcPct val="115000"/>
+              </a:lnSpc>
+            </a:pPr>
+            <a:r>
+              <a:rPr sz="1900" b="0">
+                <a:solidFill>
+                  <a:srgbClr val="14201B"/>
+                </a:solidFill>
+                <a:latin typeface="Menlo"/>
+              </a:rPr>
+              <a:t>0.675</a:t>
+            </a:r>
+          </a:p>
+        </p:txBody>
+      </p:sp>
+      <p:sp>
+        <p:nvSpPr>
+          <p:cNvPr id="25" name="Rectangle 24"/>
+          <p:cNvSpPr/>
+          <p:nvPr/>
+        </p:nvSpPr>
+        <p:spPr>
+          <a:xfrm>
+            <a:off x="658368" y="5358384"/>
+            <a:ext cx="10874959" cy="9525"/>
+          </a:xfrm>
+          <a:prstGeom prst="rect">
+            <a:avLst/>
+          </a:prstGeom>
+          <a:solidFill>
+            <a:srgbClr val="DBDBD2"/>
+          </a:solidFill>
+          <a:ln>
+            <a:noFill/>
+          </a:ln>
+          <a:effectLst/>
+        </p:spPr>
+        <p:style>
+          <a:lnRef idx="1">
+            <a:schemeClr val="accent1"/>
+          </a:lnRef>
+          <a:fillRef idx="3">
+            <a:schemeClr val="accent1"/>
+          </a:fillRef>
+          <a:effectRef idx="2">
+            <a:schemeClr val="accent1"/>
+          </a:effectRef>
+          <a:fontRef idx="minor">
+            <a:schemeClr val="lt1"/>
+          </a:fontRef>
+        </p:style>
+        <p:txBody>
+          <a:bodyPr rtlCol="0" anchor="ctr"/>
+          <a:lstStyle/>
+          <a:p>
+            <a:pPr algn="ctr"/>
+          </a:p>
+        </p:txBody>
+      </p:sp>
+      <p:sp>
+        <p:nvSpPr>
+          <p:cNvPr id="26" name="TextBox 25"/>
+          <p:cNvSpPr txBox="1"/>
+          <p:nvPr/>
+        </p:nvSpPr>
+        <p:spPr>
+          <a:xfrm>
+            <a:off x="658368" y="5833872"/>
+            <a:ext cx="10874959" cy="731520"/>
+          </a:xfrm>
+          <a:prstGeom prst="rect">
+            <a:avLst/>
+          </a:prstGeom>
+          <a:noFill/>
+        </p:spPr>
+        <p:txBody>
+          <a:bodyPr wrap="square">
+            <a:spAutoFit/>
+          </a:bodyPr>
+          <a:lstStyle/>
+          <a:p>
+            <a:pPr algn="l">
+              <a:lnSpc>
+                <a:spcPct val="125000"/>
+              </a:lnSpc>
+            </a:pPr>
+            <a:r>
+              <a:rPr sz="1600" b="0">
+                <a:solidFill>
+                  <a:srgbClr val="6B7772"/>
+                </a:solidFill>
+                <a:latin typeface="Helvetica Neue"/>
+              </a:rPr>
+              <a:t>70 unseen patients. If these rows were not level, the erasure difference would be a quality difference wearing a safety costume.</a:t>
+            </a:r>
+          </a:p>
+        </p:txBody>
+      </p:sp>
+    </p:spTree>
+  </p:cSld>
+  <p:clrMapOvr>
+    <a:masterClrMapping/>
+  </p:clrMapOvr>
+</p:sld>
+</file>
+
+<file path=ppt/slides/slide8.xml><?xml version="1.0" encoding="utf-8"?>
+<p:sld xmlns:a="http://schemas.openxmlformats.org/drawingml/2006/main" xmlns:p="http://schemas.openxmlformats.org/presentationml/2006/main" xmlns:r="http://schemas.openxmlformats.org/officeDocument/2006/relationships">
+  <p:cSld>
+    <p:bg>
+      <p:bgPr>
+        <a:solidFill>
+          <a:srgbClr val="EFEFE9"/>
+        </a:solidFill>
+        <a:effectLst/>
+      </p:bgPr>
+    </p:bg>
+    <p:spTree>
+      <p:nvGrpSpPr>
+        <p:cNvPr id="1" name=""/>
+        <p:cNvGrpSpPr/>
+        <p:nvPr/>
+      </p:nvGrpSpPr>
+      <p:grpSpPr/>
+      <p:sp>
+        <p:nvSpPr>
+          <p:cNvPr id="2" name="TextBox 1"/>
+          <p:cNvSpPr txBox="1"/>
+          <p:nvPr/>
+        </p:nvSpPr>
+        <p:spPr>
+          <a:xfrm>
+            <a:off x="658368" y="384048"/>
+            <a:ext cx="6400800" cy="365760"/>
+          </a:xfrm>
+          <a:prstGeom prst="rect">
+            <a:avLst/>
+          </a:prstGeom>
+          <a:noFill/>
+        </p:spPr>
+        <p:txBody>
+          <a:bodyPr wrap="square">
+            <a:spAutoFit/>
+          </a:bodyPr>
+          <a:lstStyle/>
+          <a:p>
+            <a:pPr algn="l">
+              <a:lnSpc>
+                <a:spcPct val="115000"/>
+              </a:lnSpc>
+            </a:pPr>
+            <a:r>
+              <a:rPr sz="1200" b="0">
+                <a:solidFill>
+                  <a:srgbClr val="0B5340"/>
+                </a:solidFill>
+                <a:latin typeface="Menlo"/>
+              </a:rPr>
+              <a:t>05  RESULT  ·  FOUR VIEWPORTS</a:t>
+            </a:r>
+          </a:p>
+        </p:txBody>
+      </p:sp>
+      <p:sp>
+        <p:nvSpPr>
+          <p:cNvPr id="3" name="TextBox 2"/>
+          <p:cNvSpPr txBox="1"/>
+          <p:nvPr/>
+        </p:nvSpPr>
+        <p:spPr>
+          <a:xfrm>
+            <a:off x="7875727" y="384048"/>
+            <a:ext cx="3657600" cy="365760"/>
+          </a:xfrm>
+          <a:prstGeom prst="rect">
+            <a:avLst/>
+          </a:prstGeom>
+          <a:noFill/>
+        </p:spPr>
+        <p:txBody>
+          <a:bodyPr wrap="square">
+            <a:spAutoFit/>
+          </a:bodyPr>
+          <a:lstStyle/>
+          <a:p>
+            <a:pPr algn="r">
+              <a:lnSpc>
+                <a:spcPct val="115000"/>
+              </a:lnSpc>
+            </a:pPr>
+            <a:r>
+              <a:rPr sz="1200" b="0">
+                <a:solidFill>
+                  <a:srgbClr val="6B7772"/>
+                </a:solidFill>
+                <a:latin typeface="Menlo"/>
+              </a:rPr>
+              <a:t>Tumor-aware SR  ·  ACVSS</a:t>
+            </a:r>
+          </a:p>
+        </p:txBody>
+      </p:sp>
+      <p:sp>
+        <p:nvSpPr>
+          <p:cNvPr id="4" name="Rectangle 3"/>
+          <p:cNvSpPr/>
+          <p:nvPr/>
+        </p:nvSpPr>
+        <p:spPr>
+          <a:xfrm>
+            <a:off x="658368" y="841248"/>
+            <a:ext cx="10874959" cy="9525"/>
+          </a:xfrm>
+          <a:prstGeom prst="rect">
+            <a:avLst/>
+          </a:prstGeom>
+          <a:solidFill>
+            <a:srgbClr val="DBDBD2"/>
+          </a:solidFill>
+          <a:ln>
+            <a:noFill/>
+          </a:ln>
+          <a:effectLst/>
+        </p:spPr>
+        <p:style>
+          <a:lnRef idx="1">
+            <a:schemeClr val="accent1"/>
+          </a:lnRef>
+          <a:fillRef idx="3">
+            <a:schemeClr val="accent1"/>
+          </a:fillRef>
+          <a:effectRef idx="2">
+            <a:schemeClr val="accent1"/>
+          </a:effectRef>
+          <a:fontRef idx="minor">
+            <a:schemeClr val="lt1"/>
+          </a:fontRef>
+        </p:style>
+        <p:txBody>
+          <a:bodyPr rtlCol="0" anchor="ctr"/>
+          <a:lstStyle/>
+          <a:p>
+            <a:pPr algn="ctr"/>
+          </a:p>
+        </p:txBody>
+      </p:sp>
+      <p:sp>
+        <p:nvSpPr>
+          <p:cNvPr id="5" name="TextBox 4"/>
+          <p:cNvSpPr txBox="1"/>
+          <p:nvPr/>
+        </p:nvSpPr>
+        <p:spPr>
+          <a:xfrm>
+            <a:off x="658368" y="1078992"/>
+            <a:ext cx="10417759" cy="1371600"/>
+          </a:xfrm>
+          <a:prstGeom prst="rect">
+            <a:avLst/>
+          </a:prstGeom>
+          <a:noFill/>
+        </p:spPr>
+        <p:txBody>
+          <a:bodyPr wrap="square">
+            <a:spAutoFit/>
+          </a:bodyPr>
+          <a:lstStyle/>
+          <a:p>
+            <a:pPr algn="l">
+              <a:lnSpc>
+                <a:spcPct val="106000"/>
+              </a:lnSpc>
+            </a:pPr>
+            <a:r>
+              <a:rPr sz="3000" b="1">
+                <a:solidFill>
+                  <a:srgbClr val="14201B"/>
+                </a:solidFill>
+                <a:latin typeface="Helvetica Neue"/>
+              </a:rPr>
+              <a:t>The lesions the baseline loses show up in 3D as empty blue shells.</a:t>
+            </a:r>
+          </a:p>
+        </p:txBody>
+      </p:sp>
+      <p:pic>
+        <p:nvPicPr>
+          <p:cNvPr id="6" name="Picture 5" descr="brain3d_true.png"/>
+          <p:cNvPicPr>
+            <a:picLocks noChangeAspect="1"/>
+          </p:cNvPicPr>
+          <p:nvPr/>
+        </p:nvPicPr>
+        <p:blipFill>
+          <a:blip r:embed="rId2"/>
+          <a:stretch>
+            <a:fillRect/>
+          </a:stretch>
+        </p:blipFill>
+        <p:spPr>
+          <a:xfrm>
+            <a:off x="658368" y="2606040"/>
+            <a:ext cx="2526715" cy="2403461"/>
+          </a:xfrm>
+          <a:prstGeom prst="rect">
+            <a:avLst/>
+          </a:prstGeom>
+        </p:spPr>
+      </p:pic>
+      <p:sp>
+        <p:nvSpPr>
+          <p:cNvPr id="7" name="TextBox 6"/>
+          <p:cNvSpPr txBox="1"/>
+          <p:nvPr/>
+        </p:nvSpPr>
+        <p:spPr>
+          <a:xfrm>
+            <a:off x="658368" y="5242483"/>
+            <a:ext cx="2526715" cy="365760"/>
+          </a:xfrm>
+          <a:prstGeom prst="rect">
+            <a:avLst/>
+          </a:prstGeom>
+          <a:noFill/>
+        </p:spPr>
+        <p:txBody>
+          <a:bodyPr wrap="square">
+            <a:spAutoFit/>
+          </a:bodyPr>
+          <a:lstStyle/>
+          <a:p>
+            <a:pPr algn="l">
+              <a:lnSpc>
+                <a:spcPct val="115000"/>
+              </a:lnSpc>
+            </a:pPr>
+            <a:r>
+              <a:rPr sz="1700" b="1">
+                <a:solidFill>
+                  <a:srgbClr val="14201B"/>
+                </a:solidFill>
+                <a:latin typeface="Helvetica Neue"/>
+              </a:rPr>
+              <a:t>Ground truth</a:t>
+            </a:r>
+          </a:p>
+        </p:txBody>
+      </p:sp>
+      <p:sp>
+        <p:nvSpPr>
+          <p:cNvPr id="8" name="TextBox 7"/>
+          <p:cNvSpPr txBox="1"/>
+          <p:nvPr/>
+        </p:nvSpPr>
+        <p:spPr>
+          <a:xfrm>
+            <a:off x="658368" y="5589955"/>
+            <a:ext cx="2526715" cy="548640"/>
+          </a:xfrm>
+          <a:prstGeom prst="rect">
+            <a:avLst/>
+          </a:prstGeom>
+          <a:noFill/>
+        </p:spPr>
+        <p:txBody>
+          <a:bodyPr wrap="square">
+            <a:spAutoFit/>
+          </a:bodyPr>
+          <a:lstStyle/>
+          <a:p>
+            <a:pPr algn="l">
+              <a:lnSpc>
+                <a:spcPct val="115000"/>
+              </a:lnSpc>
+            </a:pPr>
+            <a:r>
+              <a:rPr sz="1400" b="0">
+                <a:solidFill>
+                  <a:srgbClr val="6B7772"/>
+                </a:solidFill>
+                <a:latin typeface="Helvetica Neue"/>
+              </a:rPr>
+              <a:t>the true lesions, in blue</a:t>
+            </a:r>
+          </a:p>
+        </p:txBody>
+      </p:sp>
+      <p:pic>
+        <p:nvPicPr>
+          <p:cNvPr id="9" name="Picture 8" descr="brain3d_tumor_aware.png"/>
+          <p:cNvPicPr>
+            <a:picLocks noChangeAspect="1"/>
+          </p:cNvPicPr>
+          <p:nvPr/>
+        </p:nvPicPr>
+        <p:blipFill>
+          <a:blip r:embed="rId3"/>
+          <a:stretch>
+            <a:fillRect/>
+          </a:stretch>
+        </p:blipFill>
+        <p:spPr>
+          <a:xfrm>
+            <a:off x="3441115" y="2606040"/>
+            <a:ext cx="2526715" cy="2403461"/>
+          </a:xfrm>
+          <a:prstGeom prst="rect">
+            <a:avLst/>
+          </a:prstGeom>
+        </p:spPr>
+      </p:pic>
+      <p:sp>
+        <p:nvSpPr>
+          <p:cNvPr id="10" name="TextBox 9"/>
+          <p:cNvSpPr txBox="1"/>
+          <p:nvPr/>
+        </p:nvSpPr>
+        <p:spPr>
+          <a:xfrm>
+            <a:off x="3441115" y="5242483"/>
+            <a:ext cx="2526715" cy="365760"/>
+          </a:xfrm>
+          <a:prstGeom prst="rect">
+            <a:avLst/>
+          </a:prstGeom>
+          <a:noFill/>
+        </p:spPr>
+        <p:txBody>
+          <a:bodyPr wrap="square">
+            <a:spAutoFit/>
+          </a:bodyPr>
+          <a:lstStyle/>
+          <a:p>
+            <a:pPr algn="l">
+              <a:lnSpc>
+                <a:spcPct val="115000"/>
+              </a:lnSpc>
+            </a:pPr>
+            <a:r>
+              <a:rPr sz="1700" b="1">
+                <a:solidFill>
+                  <a:srgbClr val="14201B"/>
+                </a:solidFill>
+                <a:latin typeface="Helvetica Neue"/>
+              </a:rPr>
+              <a:t>Tumor-aware (ours)</a:t>
+            </a:r>
+          </a:p>
+        </p:txBody>
+      </p:sp>
+      <p:sp>
+        <p:nvSpPr>
+          <p:cNvPr id="11" name="TextBox 10"/>
+          <p:cNvSpPr txBox="1"/>
+          <p:nvPr/>
+        </p:nvSpPr>
+        <p:spPr>
+          <a:xfrm>
+            <a:off x="3441115" y="5589955"/>
+            <a:ext cx="2526715" cy="548640"/>
+          </a:xfrm>
+          <a:prstGeom prst="rect">
+            <a:avLst/>
+          </a:prstGeom>
+          <a:noFill/>
+        </p:spPr>
+        <p:txBody>
+          <a:bodyPr wrap="square">
+            <a:spAutoFit/>
+          </a:bodyPr>
+          <a:lstStyle/>
+          <a:p>
+            <a:pPr algn="l">
+              <a:lnSpc>
+                <a:spcPct val="115000"/>
+              </a:lnSpc>
+            </a:pPr>
+            <a:r>
+              <a:rPr sz="1400" b="0">
+                <a:solidFill>
+                  <a:srgbClr val="6B7772"/>
+                </a:solidFill>
+                <a:latin typeface="Helvetica Neue"/>
+              </a:rPr>
+              <a:t>lesions preserved</a:t>
+            </a:r>
+          </a:p>
+        </p:txBody>
+      </p:sp>
+      <p:pic>
+        <p:nvPicPr>
+          <p:cNvPr id="12" name="Picture 11" descr="brain3d_distortion.png"/>
+          <p:cNvPicPr>
+            <a:picLocks noChangeAspect="1"/>
+          </p:cNvPicPr>
+          <p:nvPr/>
+        </p:nvPicPr>
+        <p:blipFill>
+          <a:blip r:embed="rId4"/>
+          <a:stretch>
+            <a:fillRect/>
+          </a:stretch>
+        </p:blipFill>
+        <p:spPr>
+          <a:xfrm>
+            <a:off x="6223863" y="2606040"/>
+            <a:ext cx="2526715" cy="2403461"/>
+          </a:xfrm>
+          <a:prstGeom prst="rect">
+            <a:avLst/>
+          </a:prstGeom>
+        </p:spPr>
+      </p:pic>
+      <p:sp>
+        <p:nvSpPr>
           <p:cNvPr id="13" name="TextBox 12"/>
           <p:cNvSpPr txBox="1"/>
           <p:nvPr/>
         </p:nvSpPr>
         <p:spPr>
           <a:xfrm>
-            <a:off x="8469172" y="2651760"/>
-            <a:ext cx="2991002" cy="457200"/>
+            <a:off x="6223863" y="5242483"/>
+            <a:ext cx="2526715" cy="365760"/>
           </a:xfrm>
           <a:prstGeom prst="rect">
             <a:avLst/>
@@ -6353,13 +7278,13 @@
               </a:lnSpc>
             </a:pPr>
             <a:r>
-              <a:rPr sz="2000" b="1">
+              <a:rPr sz="1700" b="1">
                 <a:solidFill>
                   <a:srgbClr val="14201B"/>
                 </a:solidFill>
                 <a:latin typeface="Helvetica Neue"/>
               </a:rPr>
-              <a:t>Then the one number</a:t>
+              <a:t>Baseline</a:t>
             </a:r>
           </a:p>
         </p:txBody>
@@ -6372,8 +7297,8 @@
         </p:nvSpPr>
         <p:spPr>
           <a:xfrm>
-            <a:off x="8469172" y="3154680"/>
-            <a:ext cx="2991002" cy="1645920"/>
+            <a:off x="6223863" y="5589955"/>
+            <a:ext cx="2526715" cy="548640"/>
           </a:xfrm>
           <a:prstGeom prst="rect">
             <a:avLst/>
@@ -6388,56 +7313,158 @@
           <a:p>
             <a:pPr algn="l">
               <a:lnSpc>
-                <a:spcPct val="125000"/>
+                <a:spcPct val="115000"/>
+              </a:lnSpc>
+            </a:pPr>
+            <a:r>
+              <a:rPr sz="1400" b="0">
+                <a:solidFill>
+                  <a:srgbClr val="6B7772"/>
+                </a:solidFill>
+                <a:latin typeface="Helvetica Neue"/>
+              </a:rPr>
+              <a:t>small lesions dropped</a:t>
+            </a:r>
+          </a:p>
+        </p:txBody>
+      </p:sp>
+      <p:pic>
+        <p:nvPicPr>
+          <p:cNvPr id="15" name="Picture 14" descr="brain3d_uncertainty.png"/>
+          <p:cNvPicPr>
+            <a:picLocks noChangeAspect="1"/>
+          </p:cNvPicPr>
+          <p:nvPr/>
+        </p:nvPicPr>
+        <p:blipFill>
+          <a:blip r:embed="rId5"/>
+          <a:stretch>
+            <a:fillRect/>
+          </a:stretch>
+        </p:blipFill>
+        <p:spPr>
+          <a:xfrm>
+            <a:off x="9006611" y="2606040"/>
+            <a:ext cx="2526715" cy="2403461"/>
+          </a:xfrm>
+          <a:prstGeom prst="rect">
+            <a:avLst/>
+          </a:prstGeom>
+        </p:spPr>
+      </p:pic>
+      <p:sp>
+        <p:nvSpPr>
+          <p:cNvPr id="16" name="TextBox 15"/>
+          <p:cNvSpPr txBox="1"/>
+          <p:nvPr/>
+        </p:nvSpPr>
+        <p:spPr>
+          <a:xfrm>
+            <a:off x="9006611" y="5242483"/>
+            <a:ext cx="2526715" cy="365760"/>
+          </a:xfrm>
+          <a:prstGeom prst="rect">
+            <a:avLst/>
+          </a:prstGeom>
+          <a:noFill/>
+        </p:spPr>
+        <p:txBody>
+          <a:bodyPr wrap="square">
+            <a:spAutoFit/>
+          </a:bodyPr>
+          <a:lstStyle/>
+          <a:p>
+            <a:pPr algn="l">
+              <a:lnSpc>
+                <a:spcPct val="115000"/>
+              </a:lnSpc>
+            </a:pPr>
+            <a:r>
+              <a:rPr sz="1700" b="1">
+                <a:solidFill>
+                  <a:srgbClr val="14201B"/>
+                </a:solidFill>
+                <a:latin typeface="Helvetica Neue"/>
+              </a:rPr>
+              <a:t>Uncertainty</a:t>
+            </a:r>
+          </a:p>
+        </p:txBody>
+      </p:sp>
+      <p:sp>
+        <p:nvSpPr>
+          <p:cNvPr id="17" name="TextBox 16"/>
+          <p:cNvSpPr txBox="1"/>
+          <p:nvPr/>
+        </p:nvSpPr>
+        <p:spPr>
+          <a:xfrm>
+            <a:off x="9006611" y="5589955"/>
+            <a:ext cx="2526715" cy="548640"/>
+          </a:xfrm>
+          <a:prstGeom prst="rect">
+            <a:avLst/>
+          </a:prstGeom>
+          <a:noFill/>
+        </p:spPr>
+        <p:txBody>
+          <a:bodyPr wrap="square">
+            <a:spAutoFit/>
+          </a:bodyPr>
+          <a:lstStyle/>
+          <a:p>
+            <a:pPr algn="l">
+              <a:lnSpc>
+                <a:spcPct val="115000"/>
+              </a:lnSpc>
+            </a:pPr>
+            <a:r>
+              <a:rPr sz="1400" b="0">
+                <a:solidFill>
+                  <a:srgbClr val="6B7772"/>
+                </a:solidFill>
+                <a:latin typeface="Helvetica Neue"/>
+              </a:rPr>
+              <a:t>where the model is unsure</a:t>
+            </a:r>
+          </a:p>
+        </p:txBody>
+      </p:sp>
+      <p:sp>
+        <p:nvSpPr>
+          <p:cNvPr id="18" name="TextBox 17"/>
+          <p:cNvSpPr txBox="1"/>
+          <p:nvPr/>
+        </p:nvSpPr>
+        <p:spPr>
+          <a:xfrm>
+            <a:off x="658368" y="6172200"/>
+            <a:ext cx="10874959" cy="457200"/>
+          </a:xfrm>
+          <a:prstGeom prst="rect">
+            <a:avLst/>
+          </a:prstGeom>
+          <a:noFill/>
+        </p:spPr>
+        <p:txBody>
+          <a:bodyPr wrap="square">
+            <a:spAutoFit/>
+          </a:bodyPr>
+          <a:lstStyle/>
+          <a:p>
+            <a:pPr algn="l">
+              <a:lnSpc>
+                <a:spcPct val="115000"/>
               </a:lnSpc>
             </a:pPr>
             <a:r>
               <a:rPr sz="1600" b="0">
                 <a:solidFill>
-                  <a:srgbClr val="3D4A44"/>
+                  <a:srgbClr val="6B7772"/>
                 </a:solidFill>
                 <a:latin typeface="Helvetica Neue"/>
               </a:rPr>
-              <a:t>A single evaluation on the 94 patients nothing has touched.</a:t>
-            </a:r>
-          </a:p>
-        </p:txBody>
-      </p:sp>
-      <p:sp>
-        <p:nvSpPr>
-          <p:cNvPr id="15" name="TextBox 14"/>
-          <p:cNvSpPr txBox="1"/>
-          <p:nvPr/>
-        </p:nvSpPr>
-        <p:spPr>
-          <a:xfrm>
-            <a:off x="658368" y="5212080"/>
-            <a:ext cx="10874959" cy="548640"/>
-          </a:xfrm>
-          <a:prstGeom prst="rect">
-            <a:avLst/>
-          </a:prstGeom>
-          <a:noFill/>
-        </p:spPr>
-        <p:txBody>
-          <a:bodyPr wrap="square">
-            <a:spAutoFit/>
-          </a:bodyPr>
-          <a:lstStyle/>
-          <a:p>
-            <a:pPr algn="l">
-              <a:lnSpc>
-                <a:spcPct val="115000"/>
-              </a:lnSpc>
-            </a:pPr>
-            <a:r>
-              <a:rPr sz="1600" b="0">
-                <a:solidFill>
-                  <a:srgbClr val="6B7772"/>
-                </a:solidFill>
-                <a:latin typeface="Helvetica Neue"/>
-              </a:rPr>
-              <a:t>A safety metric is what makes a generative model testable rather than impressive.</a:t>
+              <a:t>A blue shell with nothing inside it is a lesion the model lost.</a:t>
             </a:r>
           </a:p>
         </p:txBody>

</xml_diff>